<commit_message>
Add annual activity reports for 2022 and 2025
- Created a new PDF report for the year 2022 detailing laboratory activities, including member count and publication statistics.
- Created a new PDF report for the year 2025 with similar metrics, reflecting the laboratory's status and activities during that year.
</commit_message>
<xml_diff>
--- a/docs/report/Soutenance_LIAS.pptx
+++ b/docs/report/Soutenance_LIAS.pptx
@@ -5,25 +5,25 @@
     <p:sldMasterId id="2147483648" r:id="rId1"/>
   </p:sldMasterIdLst>
   <p:sldIdLst>
-    <p:sldId id="256" r:id="rId7"/>
-    <p:sldId id="257" r:id="rId8"/>
-    <p:sldId id="258" r:id="rId9"/>
-    <p:sldId id="259" r:id="rId10"/>
-    <p:sldId id="260" r:id="rId11"/>
-    <p:sldId id="261" r:id="rId12"/>
-    <p:sldId id="262" r:id="rId13"/>
-    <p:sldId id="263" r:id="rId14"/>
-    <p:sldId id="264" r:id="rId15"/>
-    <p:sldId id="265" r:id="rId16"/>
-    <p:sldId id="266" r:id="rId17"/>
-    <p:sldId id="267" r:id="rId18"/>
-    <p:sldId id="268" r:id="rId19"/>
-    <p:sldId id="269" r:id="rId20"/>
-    <p:sldId id="270" r:id="rId21"/>
-    <p:sldId id="271" r:id="rId22"/>
-    <p:sldId id="272" r:id="rId23"/>
+    <p:sldId id="256" r:id="rId2"/>
+    <p:sldId id="257" r:id="rId3"/>
+    <p:sldId id="258" r:id="rId4"/>
+    <p:sldId id="259" r:id="rId5"/>
+    <p:sldId id="260" r:id="rId6"/>
+    <p:sldId id="261" r:id="rId7"/>
+    <p:sldId id="262" r:id="rId8"/>
+    <p:sldId id="263" r:id="rId9"/>
+    <p:sldId id="264" r:id="rId10"/>
+    <p:sldId id="265" r:id="rId11"/>
+    <p:sldId id="266" r:id="rId12"/>
+    <p:sldId id="267" r:id="rId13"/>
+    <p:sldId id="268" r:id="rId14"/>
+    <p:sldId id="269" r:id="rId15"/>
+    <p:sldId id="270" r:id="rId16"/>
+    <p:sldId id="271" r:id="rId17"/>
+    <p:sldId id="272" r:id="rId18"/>
   </p:sldIdLst>
-  <p:sldSz cx="12191695" cy="6858000" type="screen4x3"/>
+  <p:sldSz cx="12192000" cy="6858000"/>
   <p:notesSz cx="6858000" cy="9144000"/>
   <p:defaultTextStyle>
     <a:defPPr>
@@ -120,6 +120,22 @@
       </a:defRPr>
     </a:lvl9pPr>
   </p:defaultTextStyle>
+  <p:extLst>
+    <p:ext uri="{EFAFB233-063F-42B5-8137-9DF3F51BA10A}">
+      <p15:sldGuideLst xmlns:p15="http://schemas.microsoft.com/office/powerpoint/2012/main">
+        <p15:guide id="1" orient="horz" pos="2160">
+          <p15:clr>
+            <a:srgbClr val="A4A3A4"/>
+          </p15:clr>
+        </p15:guide>
+        <p15:guide id="2" pos="2880">
+          <p15:clr>
+            <a:srgbClr val="A4A3A4"/>
+          </p15:clr>
+        </p15:guide>
+      </p15:sldGuideLst>
+    </p:ext>
+  </p:extLst>
 </p:presentation>
 </file>
 
@@ -161,10 +177,9 @@
           <a:lstStyle/>
           <a:p>
             <a:r>
-              <a:rPr lang="en-US" smtClean="0"/>
+              <a:rPr lang="en-US"/>
               <a:t>Click to edit Master title style</a:t>
             </a:r>
-            <a:endParaRPr lang="en-US"/>
           </a:p>
         </p:txBody>
       </p:sp>
@@ -280,10 +295,9 @@
           </a:lstStyle>
           <a:p>
             <a:r>
-              <a:rPr lang="en-US" smtClean="0"/>
+              <a:rPr lang="en-US"/>
               <a:t>Click to edit Master subtitle style</a:t>
             </a:r>
-            <a:endParaRPr lang="en-US"/>
           </a:p>
         </p:txBody>
       </p:sp>
@@ -304,7 +318,7 @@
           <a:p>
             <a:fld id="{5BCAD085-E8A6-8845-BD4E-CB4CCA059FC4}" type="datetimeFigureOut">
               <a:rPr lang="en-US" smtClean="0"/>
-              <a:t>1/27/13</a:t>
+              <a:t>10/2/2026</a:t>
             </a:fld>
             <a:endParaRPr lang="en-US"/>
           </a:p>
@@ -346,7 +360,7 @@
           <a:p>
             <a:fld id="{C1FF6DA9-008F-8B48-92A6-B652298478BF}" type="slidenum">
               <a:rPr lang="en-US" smtClean="0"/>
-              <a:t>‹#›</a:t>
+              <a:t>‹N°›</a:t>
             </a:fld>
             <a:endParaRPr lang="en-US"/>
           </a:p>
@@ -398,10 +412,9 @@
           <a:lstStyle/>
           <a:p>
             <a:r>
-              <a:rPr lang="en-US" smtClean="0"/>
+              <a:rPr lang="en-US"/>
               <a:t>Click to edit Master title style</a:t>
             </a:r>
-            <a:endParaRPr lang="en-US"/>
           </a:p>
         </p:txBody>
       </p:sp>
@@ -422,38 +435,37 @@
           <a:p>
             <a:pPr lvl="0"/>
             <a:r>
-              <a:rPr lang="en-US" smtClean="0"/>
+              <a:rPr lang="en-US"/>
               <a:t>Click to edit Master text styles</a:t>
             </a:r>
           </a:p>
           <a:p>
             <a:pPr lvl="1"/>
             <a:r>
-              <a:rPr lang="en-US" smtClean="0"/>
+              <a:rPr lang="en-US"/>
               <a:t>Second level</a:t>
             </a:r>
           </a:p>
           <a:p>
             <a:pPr lvl="2"/>
             <a:r>
-              <a:rPr lang="en-US" smtClean="0"/>
+              <a:rPr lang="en-US"/>
               <a:t>Third level</a:t>
             </a:r>
           </a:p>
           <a:p>
             <a:pPr lvl="3"/>
             <a:r>
-              <a:rPr lang="en-US" smtClean="0"/>
+              <a:rPr lang="en-US"/>
               <a:t>Fourth level</a:t>
             </a:r>
           </a:p>
           <a:p>
             <a:pPr lvl="4"/>
             <a:r>
-              <a:rPr lang="en-US" smtClean="0"/>
+              <a:rPr lang="en-US"/>
               <a:t>Fifth level</a:t>
             </a:r>
-            <a:endParaRPr lang="en-US"/>
           </a:p>
         </p:txBody>
       </p:sp>
@@ -474,7 +486,7 @@
           <a:p>
             <a:fld id="{5BCAD085-E8A6-8845-BD4E-CB4CCA059FC4}" type="datetimeFigureOut">
               <a:rPr lang="en-US" smtClean="0"/>
-              <a:t>1/27/13</a:t>
+              <a:t>10/2/2026</a:t>
             </a:fld>
             <a:endParaRPr lang="en-US"/>
           </a:p>
@@ -516,7 +528,7 @@
           <a:p>
             <a:fld id="{C1FF6DA9-008F-8B48-92A6-B652298478BF}" type="slidenum">
               <a:rPr lang="en-US" smtClean="0"/>
-              <a:t>‹#›</a:t>
+              <a:t>‹N°›</a:t>
             </a:fld>
             <a:endParaRPr lang="en-US"/>
           </a:p>
@@ -573,10 +585,9 @@
           <a:lstStyle/>
           <a:p>
             <a:r>
-              <a:rPr lang="en-US" smtClean="0"/>
+              <a:rPr lang="en-US"/>
               <a:t>Click to edit Master title style</a:t>
             </a:r>
-            <a:endParaRPr lang="en-US"/>
           </a:p>
         </p:txBody>
       </p:sp>
@@ -602,38 +613,37 @@
           <a:p>
             <a:pPr lvl="0"/>
             <a:r>
-              <a:rPr lang="en-US" smtClean="0"/>
+              <a:rPr lang="en-US"/>
               <a:t>Click to edit Master text styles</a:t>
             </a:r>
           </a:p>
           <a:p>
             <a:pPr lvl="1"/>
             <a:r>
-              <a:rPr lang="en-US" smtClean="0"/>
+              <a:rPr lang="en-US"/>
               <a:t>Second level</a:t>
             </a:r>
           </a:p>
           <a:p>
             <a:pPr lvl="2"/>
             <a:r>
-              <a:rPr lang="en-US" smtClean="0"/>
+              <a:rPr lang="en-US"/>
               <a:t>Third level</a:t>
             </a:r>
           </a:p>
           <a:p>
             <a:pPr lvl="3"/>
             <a:r>
-              <a:rPr lang="en-US" smtClean="0"/>
+              <a:rPr lang="en-US"/>
               <a:t>Fourth level</a:t>
             </a:r>
           </a:p>
           <a:p>
             <a:pPr lvl="4"/>
             <a:r>
-              <a:rPr lang="en-US" smtClean="0"/>
+              <a:rPr lang="en-US"/>
               <a:t>Fifth level</a:t>
             </a:r>
-            <a:endParaRPr lang="en-US"/>
           </a:p>
         </p:txBody>
       </p:sp>
@@ -654,7 +664,7 @@
           <a:p>
             <a:fld id="{5BCAD085-E8A6-8845-BD4E-CB4CCA059FC4}" type="datetimeFigureOut">
               <a:rPr lang="en-US" smtClean="0"/>
-              <a:t>1/27/13</a:t>
+              <a:t>10/2/2026</a:t>
             </a:fld>
             <a:endParaRPr lang="en-US"/>
           </a:p>
@@ -696,7 +706,7 @@
           <a:p>
             <a:fld id="{C1FF6DA9-008F-8B48-92A6-B652298478BF}" type="slidenum">
               <a:rPr lang="en-US" smtClean="0"/>
-              <a:t>‹#›</a:t>
+              <a:t>‹N°›</a:t>
             </a:fld>
             <a:endParaRPr lang="en-US"/>
           </a:p>
@@ -748,10 +758,9 @@
           <a:lstStyle/>
           <a:p>
             <a:r>
-              <a:rPr lang="en-US" smtClean="0"/>
+              <a:rPr lang="en-US"/>
               <a:t>Click to edit Master title style</a:t>
             </a:r>
-            <a:endParaRPr lang="en-US"/>
           </a:p>
         </p:txBody>
       </p:sp>
@@ -772,38 +781,37 @@
           <a:p>
             <a:pPr lvl="0"/>
             <a:r>
-              <a:rPr lang="en-US" smtClean="0"/>
+              <a:rPr lang="en-US"/>
               <a:t>Click to edit Master text styles</a:t>
             </a:r>
           </a:p>
           <a:p>
             <a:pPr lvl="1"/>
             <a:r>
-              <a:rPr lang="en-US" smtClean="0"/>
+              <a:rPr lang="en-US"/>
               <a:t>Second level</a:t>
             </a:r>
           </a:p>
           <a:p>
             <a:pPr lvl="2"/>
             <a:r>
-              <a:rPr lang="en-US" smtClean="0"/>
+              <a:rPr lang="en-US"/>
               <a:t>Third level</a:t>
             </a:r>
           </a:p>
           <a:p>
             <a:pPr lvl="3"/>
             <a:r>
-              <a:rPr lang="en-US" smtClean="0"/>
+              <a:rPr lang="en-US"/>
               <a:t>Fourth level</a:t>
             </a:r>
           </a:p>
           <a:p>
             <a:pPr lvl="4"/>
             <a:r>
-              <a:rPr lang="en-US" smtClean="0"/>
+              <a:rPr lang="en-US"/>
               <a:t>Fifth level</a:t>
             </a:r>
-            <a:endParaRPr lang="en-US"/>
           </a:p>
         </p:txBody>
       </p:sp>
@@ -824,7 +832,7 @@
           <a:p>
             <a:fld id="{5BCAD085-E8A6-8845-BD4E-CB4CCA059FC4}" type="datetimeFigureOut">
               <a:rPr lang="en-US" smtClean="0"/>
-              <a:t>1/27/13</a:t>
+              <a:t>10/2/2026</a:t>
             </a:fld>
             <a:endParaRPr lang="en-US"/>
           </a:p>
@@ -866,7 +874,7 @@
           <a:p>
             <a:fld id="{C1FF6DA9-008F-8B48-92A6-B652298478BF}" type="slidenum">
               <a:rPr lang="en-US" smtClean="0"/>
-              <a:t>‹#›</a:t>
+              <a:t>‹N°›</a:t>
             </a:fld>
             <a:endParaRPr lang="en-US"/>
           </a:p>
@@ -927,10 +935,9 @@
           </a:lstStyle>
           <a:p>
             <a:r>
-              <a:rPr lang="en-US" smtClean="0"/>
+              <a:rPr lang="en-US"/>
               <a:t>Click to edit Master title style</a:t>
             </a:r>
-            <a:endParaRPr lang="en-US"/>
           </a:p>
         </p:txBody>
       </p:sp>
@@ -1047,7 +1054,7 @@
           <a:p>
             <a:pPr lvl="0"/>
             <a:r>
-              <a:rPr lang="en-US" smtClean="0"/>
+              <a:rPr lang="en-US"/>
               <a:t>Click to edit Master text styles</a:t>
             </a:r>
           </a:p>
@@ -1070,7 +1077,7 @@
           <a:p>
             <a:fld id="{5BCAD085-E8A6-8845-BD4E-CB4CCA059FC4}" type="datetimeFigureOut">
               <a:rPr lang="en-US" smtClean="0"/>
-              <a:t>1/27/13</a:t>
+              <a:t>10/2/2026</a:t>
             </a:fld>
             <a:endParaRPr lang="en-US"/>
           </a:p>
@@ -1112,7 +1119,7 @@
           <a:p>
             <a:fld id="{C1FF6DA9-008F-8B48-92A6-B652298478BF}" type="slidenum">
               <a:rPr lang="en-US" smtClean="0"/>
-              <a:t>‹#›</a:t>
+              <a:t>‹N°›</a:t>
             </a:fld>
             <a:endParaRPr lang="en-US"/>
           </a:p>
@@ -1164,10 +1171,9 @@
           <a:lstStyle/>
           <a:p>
             <a:r>
-              <a:rPr lang="en-US" smtClean="0"/>
+              <a:rPr lang="en-US"/>
               <a:t>Click to edit Master title style</a:t>
             </a:r>
-            <a:endParaRPr lang="en-US"/>
           </a:p>
         </p:txBody>
       </p:sp>
@@ -1221,38 +1227,37 @@
           <a:p>
             <a:pPr lvl="0"/>
             <a:r>
-              <a:rPr lang="en-US" smtClean="0"/>
+              <a:rPr lang="en-US"/>
               <a:t>Click to edit Master text styles</a:t>
             </a:r>
           </a:p>
           <a:p>
             <a:pPr lvl="1"/>
             <a:r>
-              <a:rPr lang="en-US" smtClean="0"/>
+              <a:rPr lang="en-US"/>
               <a:t>Second level</a:t>
             </a:r>
           </a:p>
           <a:p>
             <a:pPr lvl="2"/>
             <a:r>
-              <a:rPr lang="en-US" smtClean="0"/>
+              <a:rPr lang="en-US"/>
               <a:t>Third level</a:t>
             </a:r>
           </a:p>
           <a:p>
             <a:pPr lvl="3"/>
             <a:r>
-              <a:rPr lang="en-US" smtClean="0"/>
+              <a:rPr lang="en-US"/>
               <a:t>Fourth level</a:t>
             </a:r>
           </a:p>
           <a:p>
             <a:pPr lvl="4"/>
             <a:r>
-              <a:rPr lang="en-US" smtClean="0"/>
+              <a:rPr lang="en-US"/>
               <a:t>Fifth level</a:t>
             </a:r>
-            <a:endParaRPr lang="en-US"/>
           </a:p>
         </p:txBody>
       </p:sp>
@@ -1306,38 +1311,37 @@
           <a:p>
             <a:pPr lvl="0"/>
             <a:r>
-              <a:rPr lang="en-US" smtClean="0"/>
+              <a:rPr lang="en-US"/>
               <a:t>Click to edit Master text styles</a:t>
             </a:r>
           </a:p>
           <a:p>
             <a:pPr lvl="1"/>
             <a:r>
-              <a:rPr lang="en-US" smtClean="0"/>
+              <a:rPr lang="en-US"/>
               <a:t>Second level</a:t>
             </a:r>
           </a:p>
           <a:p>
             <a:pPr lvl="2"/>
             <a:r>
-              <a:rPr lang="en-US" smtClean="0"/>
+              <a:rPr lang="en-US"/>
               <a:t>Third level</a:t>
             </a:r>
           </a:p>
           <a:p>
             <a:pPr lvl="3"/>
             <a:r>
-              <a:rPr lang="en-US" smtClean="0"/>
+              <a:rPr lang="en-US"/>
               <a:t>Fourth level</a:t>
             </a:r>
           </a:p>
           <a:p>
             <a:pPr lvl="4"/>
             <a:r>
-              <a:rPr lang="en-US" smtClean="0"/>
+              <a:rPr lang="en-US"/>
               <a:t>Fifth level</a:t>
             </a:r>
-            <a:endParaRPr lang="en-US"/>
           </a:p>
         </p:txBody>
       </p:sp>
@@ -1358,7 +1362,7 @@
           <a:p>
             <a:fld id="{5BCAD085-E8A6-8845-BD4E-CB4CCA059FC4}" type="datetimeFigureOut">
               <a:rPr lang="en-US" smtClean="0"/>
-              <a:t>1/27/13</a:t>
+              <a:t>10/2/2026</a:t>
             </a:fld>
             <a:endParaRPr lang="en-US"/>
           </a:p>
@@ -1400,7 +1404,7 @@
           <a:p>
             <a:fld id="{C1FF6DA9-008F-8B48-92A6-B652298478BF}" type="slidenum">
               <a:rPr lang="en-US" smtClean="0"/>
-              <a:t>‹#›</a:t>
+              <a:t>‹N°›</a:t>
             </a:fld>
             <a:endParaRPr lang="en-US"/>
           </a:p>
@@ -1456,10 +1460,9 @@
           </a:lstStyle>
           <a:p>
             <a:r>
-              <a:rPr lang="en-US" smtClean="0"/>
+              <a:rPr lang="en-US"/>
               <a:t>Click to edit Master title style</a:t>
             </a:r>
-            <a:endParaRPr lang="en-US"/>
           </a:p>
         </p:txBody>
       </p:sp>
@@ -1522,7 +1525,7 @@
           <a:p>
             <a:pPr lvl="0"/>
             <a:r>
-              <a:rPr lang="en-US" smtClean="0"/>
+              <a:rPr lang="en-US"/>
               <a:t>Click to edit Master text styles</a:t>
             </a:r>
           </a:p>
@@ -1578,38 +1581,37 @@
           <a:p>
             <a:pPr lvl="0"/>
             <a:r>
-              <a:rPr lang="en-US" smtClean="0"/>
+              <a:rPr lang="en-US"/>
               <a:t>Click to edit Master text styles</a:t>
             </a:r>
           </a:p>
           <a:p>
             <a:pPr lvl="1"/>
             <a:r>
-              <a:rPr lang="en-US" smtClean="0"/>
+              <a:rPr lang="en-US"/>
               <a:t>Second level</a:t>
             </a:r>
           </a:p>
           <a:p>
             <a:pPr lvl="2"/>
             <a:r>
-              <a:rPr lang="en-US" smtClean="0"/>
+              <a:rPr lang="en-US"/>
               <a:t>Third level</a:t>
             </a:r>
           </a:p>
           <a:p>
             <a:pPr lvl="3"/>
             <a:r>
-              <a:rPr lang="en-US" smtClean="0"/>
+              <a:rPr lang="en-US"/>
               <a:t>Fourth level</a:t>
             </a:r>
           </a:p>
           <a:p>
             <a:pPr lvl="4"/>
             <a:r>
-              <a:rPr lang="en-US" smtClean="0"/>
+              <a:rPr lang="en-US"/>
               <a:t>Fifth level</a:t>
             </a:r>
-            <a:endParaRPr lang="en-US"/>
           </a:p>
         </p:txBody>
       </p:sp>
@@ -1672,7 +1674,7 @@
           <a:p>
             <a:pPr lvl="0"/>
             <a:r>
-              <a:rPr lang="en-US" smtClean="0"/>
+              <a:rPr lang="en-US"/>
               <a:t>Click to edit Master text styles</a:t>
             </a:r>
           </a:p>
@@ -1728,38 +1730,37 @@
           <a:p>
             <a:pPr lvl="0"/>
             <a:r>
-              <a:rPr lang="en-US" smtClean="0"/>
+              <a:rPr lang="en-US"/>
               <a:t>Click to edit Master text styles</a:t>
             </a:r>
           </a:p>
           <a:p>
             <a:pPr lvl="1"/>
             <a:r>
-              <a:rPr lang="en-US" smtClean="0"/>
+              <a:rPr lang="en-US"/>
               <a:t>Second level</a:t>
             </a:r>
           </a:p>
           <a:p>
             <a:pPr lvl="2"/>
             <a:r>
-              <a:rPr lang="en-US" smtClean="0"/>
+              <a:rPr lang="en-US"/>
               <a:t>Third level</a:t>
             </a:r>
           </a:p>
           <a:p>
             <a:pPr lvl="3"/>
             <a:r>
-              <a:rPr lang="en-US" smtClean="0"/>
+              <a:rPr lang="en-US"/>
               <a:t>Fourth level</a:t>
             </a:r>
           </a:p>
           <a:p>
             <a:pPr lvl="4"/>
             <a:r>
-              <a:rPr lang="en-US" smtClean="0"/>
+              <a:rPr lang="en-US"/>
               <a:t>Fifth level</a:t>
             </a:r>
-            <a:endParaRPr lang="en-US"/>
           </a:p>
         </p:txBody>
       </p:sp>
@@ -1780,7 +1781,7 @@
           <a:p>
             <a:fld id="{5BCAD085-E8A6-8845-BD4E-CB4CCA059FC4}" type="datetimeFigureOut">
               <a:rPr lang="en-US" smtClean="0"/>
-              <a:t>1/27/13</a:t>
+              <a:t>10/2/2026</a:t>
             </a:fld>
             <a:endParaRPr lang="en-US"/>
           </a:p>
@@ -1822,7 +1823,7 @@
           <a:p>
             <a:fld id="{C1FF6DA9-008F-8B48-92A6-B652298478BF}" type="slidenum">
               <a:rPr lang="en-US" smtClean="0"/>
-              <a:t>‹#›</a:t>
+              <a:t>‹N°›</a:t>
             </a:fld>
             <a:endParaRPr lang="en-US"/>
           </a:p>
@@ -1874,10 +1875,9 @@
           <a:lstStyle/>
           <a:p>
             <a:r>
-              <a:rPr lang="en-US" smtClean="0"/>
+              <a:rPr lang="en-US"/>
               <a:t>Click to edit Master title style</a:t>
             </a:r>
-            <a:endParaRPr lang="en-US"/>
           </a:p>
         </p:txBody>
       </p:sp>
@@ -1898,7 +1898,7 @@
           <a:p>
             <a:fld id="{5BCAD085-E8A6-8845-BD4E-CB4CCA059FC4}" type="datetimeFigureOut">
               <a:rPr lang="en-US" smtClean="0"/>
-              <a:t>1/27/13</a:t>
+              <a:t>10/2/2026</a:t>
             </a:fld>
             <a:endParaRPr lang="en-US"/>
           </a:p>
@@ -1940,7 +1940,7 @@
           <a:p>
             <a:fld id="{C1FF6DA9-008F-8B48-92A6-B652298478BF}" type="slidenum">
               <a:rPr lang="en-US" smtClean="0"/>
-              <a:t>‹#›</a:t>
+              <a:t>‹N°›</a:t>
             </a:fld>
             <a:endParaRPr lang="en-US"/>
           </a:p>
@@ -1993,7 +1993,7 @@
           <a:p>
             <a:fld id="{5BCAD085-E8A6-8845-BD4E-CB4CCA059FC4}" type="datetimeFigureOut">
               <a:rPr lang="en-US" smtClean="0"/>
-              <a:t>1/27/13</a:t>
+              <a:t>10/2/2026</a:t>
             </a:fld>
             <a:endParaRPr lang="en-US"/>
           </a:p>
@@ -2035,7 +2035,7 @@
           <a:p>
             <a:fld id="{C1FF6DA9-008F-8B48-92A6-B652298478BF}" type="slidenum">
               <a:rPr lang="en-US" smtClean="0"/>
-              <a:t>‹#›</a:t>
+              <a:t>‹N°›</a:t>
             </a:fld>
             <a:endParaRPr lang="en-US"/>
           </a:p>
@@ -2096,10 +2096,9 @@
           </a:lstStyle>
           <a:p>
             <a:r>
-              <a:rPr lang="en-US" smtClean="0"/>
+              <a:rPr lang="en-US"/>
               <a:t>Click to edit Master title style</a:t>
             </a:r>
-            <a:endParaRPr lang="en-US"/>
           </a:p>
         </p:txBody>
       </p:sp>
@@ -2153,38 +2152,37 @@
           <a:p>
             <a:pPr lvl="0"/>
             <a:r>
-              <a:rPr lang="en-US" smtClean="0"/>
+              <a:rPr lang="en-US"/>
               <a:t>Click to edit Master text styles</a:t>
             </a:r>
           </a:p>
           <a:p>
             <a:pPr lvl="1"/>
             <a:r>
-              <a:rPr lang="en-US" smtClean="0"/>
+              <a:rPr lang="en-US"/>
               <a:t>Second level</a:t>
             </a:r>
           </a:p>
           <a:p>
             <a:pPr lvl="2"/>
             <a:r>
-              <a:rPr lang="en-US" smtClean="0"/>
+              <a:rPr lang="en-US"/>
               <a:t>Third level</a:t>
             </a:r>
           </a:p>
           <a:p>
             <a:pPr lvl="3"/>
             <a:r>
-              <a:rPr lang="en-US" smtClean="0"/>
+              <a:rPr lang="en-US"/>
               <a:t>Fourth level</a:t>
             </a:r>
           </a:p>
           <a:p>
             <a:pPr lvl="4"/>
             <a:r>
-              <a:rPr lang="en-US" smtClean="0"/>
+              <a:rPr lang="en-US"/>
               <a:t>Fifth level</a:t>
             </a:r>
-            <a:endParaRPr lang="en-US"/>
           </a:p>
         </p:txBody>
       </p:sp>
@@ -2247,7 +2245,7 @@
           <a:p>
             <a:pPr lvl="0"/>
             <a:r>
-              <a:rPr lang="en-US" smtClean="0"/>
+              <a:rPr lang="en-US"/>
               <a:t>Click to edit Master text styles</a:t>
             </a:r>
           </a:p>
@@ -2270,7 +2268,7 @@
           <a:p>
             <a:fld id="{5BCAD085-E8A6-8845-BD4E-CB4CCA059FC4}" type="datetimeFigureOut">
               <a:rPr lang="en-US" smtClean="0"/>
-              <a:t>1/27/13</a:t>
+              <a:t>10/2/2026</a:t>
             </a:fld>
             <a:endParaRPr lang="en-US"/>
           </a:p>
@@ -2312,7 +2310,7 @@
           <a:p>
             <a:fld id="{C1FF6DA9-008F-8B48-92A6-B652298478BF}" type="slidenum">
               <a:rPr lang="en-US" smtClean="0"/>
-              <a:t>‹#›</a:t>
+              <a:t>‹N°›</a:t>
             </a:fld>
             <a:endParaRPr lang="en-US"/>
           </a:p>
@@ -2373,10 +2371,9 @@
           </a:lstStyle>
           <a:p>
             <a:r>
-              <a:rPr lang="en-US" smtClean="0"/>
+              <a:rPr lang="en-US"/>
               <a:t>Click to edit Master title style</a:t>
             </a:r>
-            <a:endParaRPr lang="en-US"/>
           </a:p>
         </p:txBody>
       </p:sp>
@@ -2500,7 +2497,7 @@
           <a:p>
             <a:pPr lvl="0"/>
             <a:r>
-              <a:rPr lang="en-US" smtClean="0"/>
+              <a:rPr lang="en-US"/>
               <a:t>Click to edit Master text styles</a:t>
             </a:r>
           </a:p>
@@ -2523,7 +2520,7 @@
           <a:p>
             <a:fld id="{5BCAD085-E8A6-8845-BD4E-CB4CCA059FC4}" type="datetimeFigureOut">
               <a:rPr lang="en-US" smtClean="0"/>
-              <a:t>1/27/13</a:t>
+              <a:t>10/2/2026</a:t>
             </a:fld>
             <a:endParaRPr lang="en-US"/>
           </a:p>
@@ -2565,7 +2562,7 @@
           <a:p>
             <a:fld id="{C1FF6DA9-008F-8B48-92A6-B652298478BF}" type="slidenum">
               <a:rPr lang="en-US" smtClean="0"/>
-              <a:t>‹#›</a:t>
+              <a:t>‹N°›</a:t>
             </a:fld>
             <a:endParaRPr lang="en-US"/>
           </a:p>
@@ -2632,10 +2629,9 @@
           <a:lstStyle/>
           <a:p>
             <a:r>
-              <a:rPr lang="en-US" smtClean="0"/>
+              <a:rPr lang="en-US"/>
               <a:t>Click to edit Master title style</a:t>
             </a:r>
-            <a:endParaRPr lang="en-US"/>
           </a:p>
         </p:txBody>
       </p:sp>
@@ -2666,38 +2662,37 @@
           <a:p>
             <a:pPr lvl="0"/>
             <a:r>
-              <a:rPr lang="en-US" smtClean="0"/>
+              <a:rPr lang="en-US"/>
               <a:t>Click to edit Master text styles</a:t>
             </a:r>
           </a:p>
           <a:p>
             <a:pPr lvl="1"/>
             <a:r>
-              <a:rPr lang="en-US" smtClean="0"/>
+              <a:rPr lang="en-US"/>
               <a:t>Second level</a:t>
             </a:r>
           </a:p>
           <a:p>
             <a:pPr lvl="2"/>
             <a:r>
-              <a:rPr lang="en-US" smtClean="0"/>
+              <a:rPr lang="en-US"/>
               <a:t>Third level</a:t>
             </a:r>
           </a:p>
           <a:p>
             <a:pPr lvl="3"/>
             <a:r>
-              <a:rPr lang="en-US" smtClean="0"/>
+              <a:rPr lang="en-US"/>
               <a:t>Fourth level</a:t>
             </a:r>
           </a:p>
           <a:p>
             <a:pPr lvl="4"/>
             <a:r>
-              <a:rPr lang="en-US" smtClean="0"/>
+              <a:rPr lang="en-US"/>
               <a:t>Fifth level</a:t>
             </a:r>
-            <a:endParaRPr lang="en-US"/>
           </a:p>
         </p:txBody>
       </p:sp>
@@ -2736,7 +2731,7 @@
           <a:p>
             <a:fld id="{5BCAD085-E8A6-8845-BD4E-CB4CCA059FC4}" type="datetimeFigureOut">
               <a:rPr lang="en-US" smtClean="0"/>
-              <a:t>1/27/13</a:t>
+              <a:t>10/2/2026</a:t>
             </a:fld>
             <a:endParaRPr lang="en-US"/>
           </a:p>
@@ -2814,7 +2809,7 @@
           <a:p>
             <a:fld id="{C1FF6DA9-008F-8B48-92A6-B652298478BF}" type="slidenum">
               <a:rPr lang="en-US" smtClean="0"/>
-              <a:t>‹#›</a:t>
+              <a:t>‹N°›</a:t>
             </a:fld>
             <a:endParaRPr lang="en-US"/>
           </a:p>
@@ -3095,7 +3090,7 @@
 </file>
 
 <file path=ppt/slides/slide1.xml><?xml version="1.0" encoding="utf-8"?>
-<p:sld xmlns:a="http://schemas.openxmlformats.org/drawingml/2006/main" xmlns:p="http://schemas.openxmlformats.org/presentationml/2006/main" xmlns:r="http://schemas.openxmlformats.org/officeDocument/2006/relationships">
+<p:sld xmlns:a="http://schemas.openxmlformats.org/drawingml/2006/main" xmlns:r="http://schemas.openxmlformats.org/officeDocument/2006/relationships" xmlns:p="http://schemas.openxmlformats.org/presentationml/2006/main">
   <p:cSld>
     <p:spTree>
       <p:nvGrpSpPr>
@@ -3103,7 +3098,14 @@
         <p:cNvGrpSpPr/>
         <p:nvPr/>
       </p:nvGrpSpPr>
-      <p:grpSpPr/>
+      <p:grpSpPr>
+        <a:xfrm>
+          <a:off x="0" y="0"/>
+          <a:ext cx="0" cy="0"/>
+          <a:chOff x="0" y="0"/>
+          <a:chExt cx="0" cy="0"/>
+        </a:xfrm>
+      </p:grpSpPr>
       <p:sp>
         <p:nvSpPr>
           <p:cNvPr id="2" name="Rectangle 1"/>
@@ -3145,6 +3147,7 @@
           <a:lstStyle/>
           <a:p>
             <a:pPr algn="ctr"/>
+            <a:endParaRPr/>
           </a:p>
         </p:txBody>
       </p:sp>
@@ -3189,6 +3192,7 @@
           <a:lstStyle/>
           <a:p>
             <a:pPr algn="ctr"/>
+            <a:endParaRPr/>
           </a:p>
         </p:txBody>
       </p:sp>
@@ -3233,6 +3237,7 @@
           <a:lstStyle/>
           <a:p>
             <a:pPr algn="ctr"/>
+            <a:endParaRPr/>
           </a:p>
         </p:txBody>
       </p:sp>
@@ -3301,7 +3306,7 @@
           <a:noFill/>
         </p:spPr>
         <p:txBody>
-          <a:bodyPr wrap="square" anchor="t" lIns="0" rIns="0" tIns="0" bIns="0">
+          <a:bodyPr wrap="square" lIns="0" tIns="0" rIns="0" bIns="0" anchor="t">
             <a:spAutoFit/>
           </a:bodyPr>
           <a:lstStyle/>
@@ -3343,7 +3348,7 @@
           <a:noFill/>
         </p:spPr>
         <p:txBody>
-          <a:bodyPr wrap="square" anchor="t" lIns="0" rIns="0" tIns="0" bIns="0">
+          <a:bodyPr wrap="square" lIns="0" tIns="0" rIns="0" bIns="0" anchor="t">
             <a:spAutoFit/>
           </a:bodyPr>
           <a:lstStyle/>
@@ -3409,6 +3414,7 @@
           <a:lstStyle/>
           <a:p>
             <a:pPr algn="ctr"/>
+            <a:endParaRPr/>
           </a:p>
         </p:txBody>
       </p:sp>
@@ -3429,7 +3435,7 @@
           <a:noFill/>
         </p:spPr>
         <p:txBody>
-          <a:bodyPr wrap="square" anchor="t" lIns="0" rIns="0" tIns="0" bIns="0">
+          <a:bodyPr wrap="square" lIns="0" tIns="0" rIns="0" bIns="0" anchor="t">
             <a:spAutoFit/>
           </a:bodyPr>
           <a:lstStyle/>
@@ -3471,7 +3477,7 @@
           <a:noFill/>
         </p:spPr>
         <p:txBody>
-          <a:bodyPr wrap="square" anchor="t" lIns="0" rIns="0" tIns="0" bIns="0">
+          <a:bodyPr wrap="square" lIns="0" tIns="0" rIns="0" bIns="0" anchor="t">
             <a:spAutoFit/>
           </a:bodyPr>
           <a:lstStyle/>
@@ -3580,6 +3586,7 @@
           <a:lstStyle/>
           <a:p>
             <a:pPr algn="ctr"/>
+            <a:endParaRPr/>
           </a:p>
         </p:txBody>
       </p:sp>
@@ -3600,7 +3607,7 @@
           <a:noFill/>
         </p:spPr>
         <p:txBody>
-          <a:bodyPr wrap="square" anchor="t" lIns="0" rIns="0" tIns="0" bIns="0">
+          <a:bodyPr wrap="square" lIns="0" tIns="0" rIns="0" bIns="0" anchor="t">
             <a:spAutoFit/>
           </a:bodyPr>
           <a:lstStyle/>
@@ -3642,7 +3649,7 @@
           <a:noFill/>
         </p:spPr>
         <p:txBody>
-          <a:bodyPr wrap="square" anchor="t" lIns="0" rIns="0" tIns="0" bIns="0">
+          <a:bodyPr wrap="square" lIns="0" tIns="0" rIns="0" bIns="0" anchor="t">
             <a:spAutoFit/>
           </a:bodyPr>
           <a:lstStyle/>
@@ -3684,7 +3691,7 @@
           <a:noFill/>
         </p:spPr>
         <p:txBody>
-          <a:bodyPr wrap="square" anchor="t" lIns="0" rIns="0" tIns="0" bIns="0">
+          <a:bodyPr wrap="square" lIns="0" tIns="0" rIns="0" bIns="0" anchor="t">
             <a:spAutoFit/>
           </a:bodyPr>
           <a:lstStyle/>
@@ -3726,7 +3733,7 @@
           <a:noFill/>
         </p:spPr>
         <p:txBody>
-          <a:bodyPr wrap="square" anchor="t" lIns="0" rIns="0" tIns="0" bIns="0">
+          <a:bodyPr wrap="square" lIns="0" tIns="0" rIns="0" bIns="0" anchor="t">
             <a:spAutoFit/>
           </a:bodyPr>
           <a:lstStyle/>
@@ -3756,11 +3763,23 @@
   <p:clrMapOvr>
     <a:masterClrMapping/>
   </p:clrMapOvr>
+  <mc:AlternateContent xmlns:mc="http://schemas.openxmlformats.org/markup-compatibility/2006">
+    <mc:Choice xmlns:p159="http://schemas.microsoft.com/office/powerpoint/2015/09/main" Requires="p159">
+      <p:transition xmlns:p14="http://schemas.microsoft.com/office/powerpoint/2010/main" spd="slow" p14:dur="2000">
+        <p159:morph option="byObject"/>
+      </p:transition>
+    </mc:Choice>
+    <mc:Fallback>
+      <p:transition spd="slow">
+        <p:fade/>
+      </p:transition>
+    </mc:Fallback>
+  </mc:AlternateContent>
 </p:sld>
 </file>
 
 <file path=ppt/slides/slide10.xml><?xml version="1.0" encoding="utf-8"?>
-<p:sld xmlns:a="http://schemas.openxmlformats.org/drawingml/2006/main" xmlns:p="http://schemas.openxmlformats.org/presentationml/2006/main" xmlns:r="http://schemas.openxmlformats.org/officeDocument/2006/relationships">
+<p:sld xmlns:a="http://schemas.openxmlformats.org/drawingml/2006/main" xmlns:r="http://schemas.openxmlformats.org/officeDocument/2006/relationships" xmlns:p="http://schemas.openxmlformats.org/presentationml/2006/main">
   <p:cSld>
     <p:spTree>
       <p:nvGrpSpPr>
@@ -3768,7 +3787,14 @@
         <p:cNvGrpSpPr/>
         <p:nvPr/>
       </p:nvGrpSpPr>
-      <p:grpSpPr/>
+      <p:grpSpPr>
+        <a:xfrm>
+          <a:off x="0" y="0"/>
+          <a:ext cx="0" cy="0"/>
+          <a:chOff x="0" y="0"/>
+          <a:chExt cx="0" cy="0"/>
+        </a:xfrm>
+      </p:grpSpPr>
       <p:sp>
         <p:nvSpPr>
           <p:cNvPr id="2" name="Rectangle 1"/>
@@ -3810,6 +3836,7 @@
           <a:lstStyle/>
           <a:p>
             <a:pPr algn="ctr"/>
+            <a:endParaRPr/>
           </a:p>
         </p:txBody>
       </p:sp>
@@ -3854,6 +3881,7 @@
           <a:lstStyle/>
           <a:p>
             <a:pPr algn="ctr"/>
+            <a:endParaRPr/>
           </a:p>
         </p:txBody>
       </p:sp>
@@ -3874,7 +3902,7 @@
           <a:noFill/>
         </p:spPr>
         <p:txBody>
-          <a:bodyPr wrap="square" anchor="t" lIns="0" rIns="0" tIns="0" bIns="0">
+          <a:bodyPr wrap="square" lIns="0" tIns="0" rIns="0" bIns="0" anchor="t">
             <a:spAutoFit/>
           </a:bodyPr>
           <a:lstStyle/>
@@ -3916,7 +3944,7 @@
           <a:noFill/>
         </p:spPr>
         <p:txBody>
-          <a:bodyPr wrap="square" anchor="t" lIns="0" rIns="0" tIns="0" bIns="0">
+          <a:bodyPr wrap="square" lIns="0" tIns="0" rIns="0" bIns="0" anchor="t">
             <a:spAutoFit/>
           </a:bodyPr>
           <a:lstStyle/>
@@ -3958,7 +3986,7 @@
           <a:noFill/>
         </p:spPr>
         <p:txBody>
-          <a:bodyPr wrap="square" anchor="t" lIns="0" rIns="0" tIns="0" bIns="0">
+          <a:bodyPr wrap="square" lIns="0" tIns="0" rIns="0" bIns="0" anchor="t">
             <a:spAutoFit/>
           </a:bodyPr>
           <a:lstStyle/>
@@ -4048,6 +4076,7 @@
           <a:lstStyle/>
           <a:p>
             <a:pPr algn="ctr"/>
+            <a:endParaRPr/>
           </a:p>
         </p:txBody>
       </p:sp>
@@ -4068,7 +4097,7 @@
           <a:noFill/>
         </p:spPr>
         <p:txBody>
-          <a:bodyPr wrap="square" anchor="t" lIns="0" rIns="0" tIns="0" bIns="0">
+          <a:bodyPr wrap="square" lIns="0" tIns="0" rIns="0" bIns="0" anchor="t">
             <a:spAutoFit/>
           </a:bodyPr>
           <a:lstStyle/>
@@ -4110,7 +4139,7 @@
           <a:noFill/>
         </p:spPr>
         <p:txBody>
-          <a:bodyPr wrap="square" anchor="t" lIns="0" rIns="0" tIns="0" bIns="0">
+          <a:bodyPr wrap="square" lIns="0" tIns="0" rIns="0" bIns="0" anchor="t">
             <a:spAutoFit/>
           </a:bodyPr>
           <a:lstStyle/>
@@ -4176,6 +4205,7 @@
           <a:lstStyle/>
           <a:p>
             <a:pPr algn="ctr"/>
+            <a:endParaRPr/>
           </a:p>
         </p:txBody>
       </p:sp>
@@ -4220,6 +4250,7 @@
           <a:lstStyle/>
           <a:p>
             <a:pPr algn="ctr"/>
+            <a:endParaRPr/>
           </a:p>
         </p:txBody>
       </p:sp>
@@ -4240,7 +4271,7 @@
           <a:noFill/>
         </p:spPr>
         <p:txBody>
-          <a:bodyPr wrap="square" anchor="t" lIns="0" rIns="0" tIns="0" bIns="0">
+          <a:bodyPr wrap="square" lIns="0" tIns="0" rIns="0" bIns="0" anchor="t">
             <a:spAutoFit/>
           </a:bodyPr>
           <a:lstStyle/>
@@ -4282,7 +4313,7 @@
           <a:noFill/>
         </p:spPr>
         <p:txBody>
-          <a:bodyPr wrap="square" anchor="t" lIns="0" rIns="0" tIns="0" bIns="0">
+          <a:bodyPr wrap="square" lIns="0" tIns="0" rIns="0" bIns="0" anchor="t">
             <a:spAutoFit/>
           </a:bodyPr>
           <a:lstStyle/>
@@ -4348,6 +4379,7 @@
           <a:lstStyle/>
           <a:p>
             <a:pPr algn="ctr"/>
+            <a:endParaRPr/>
           </a:p>
         </p:txBody>
       </p:sp>
@@ -4368,7 +4400,7 @@
           <a:noFill/>
         </p:spPr>
         <p:txBody>
-          <a:bodyPr wrap="square" anchor="t" lIns="0" rIns="0" tIns="0" bIns="0">
+          <a:bodyPr wrap="square" lIns="0" tIns="0" rIns="0" bIns="0" anchor="t">
             <a:spAutoFit/>
           </a:bodyPr>
           <a:lstStyle/>
@@ -4434,6 +4466,7 @@
           <a:lstStyle/>
           <a:p>
             <a:pPr algn="ctr"/>
+            <a:endParaRPr/>
           </a:p>
         </p:txBody>
       </p:sp>
@@ -4454,7 +4487,7 @@
           <a:noFill/>
         </p:spPr>
         <p:txBody>
-          <a:bodyPr wrap="square" anchor="t" lIns="0" rIns="0" tIns="0" bIns="0">
+          <a:bodyPr wrap="square" lIns="0" tIns="0" rIns="0" bIns="0" anchor="t">
             <a:spAutoFit/>
           </a:bodyPr>
           <a:lstStyle/>
@@ -4520,6 +4553,7 @@
           <a:lstStyle/>
           <a:p>
             <a:pPr algn="ctr"/>
+            <a:endParaRPr/>
           </a:p>
         </p:txBody>
       </p:sp>
@@ -4540,7 +4574,7 @@
           <a:noFill/>
         </p:spPr>
         <p:txBody>
-          <a:bodyPr wrap="square" anchor="t" lIns="0" rIns="0" tIns="0" bIns="0">
+          <a:bodyPr wrap="square" lIns="0" tIns="0" rIns="0" bIns="0" anchor="t">
             <a:spAutoFit/>
           </a:bodyPr>
           <a:lstStyle/>
@@ -4606,6 +4640,7 @@
           <a:lstStyle/>
           <a:p>
             <a:pPr algn="ctr"/>
+            <a:endParaRPr/>
           </a:p>
         </p:txBody>
       </p:sp>
@@ -4626,7 +4661,7 @@
           <a:noFill/>
         </p:spPr>
         <p:txBody>
-          <a:bodyPr wrap="square" anchor="t" lIns="0" rIns="0" tIns="0" bIns="0">
+          <a:bodyPr wrap="square" lIns="0" tIns="0" rIns="0" bIns="0" anchor="t">
             <a:spAutoFit/>
           </a:bodyPr>
           <a:lstStyle/>
@@ -4668,7 +4703,7 @@
           <a:noFill/>
         </p:spPr>
         <p:txBody>
-          <a:bodyPr wrap="square" anchor="t" lIns="0" rIns="0" tIns="0" bIns="0">
+          <a:bodyPr wrap="square" lIns="0" tIns="0" rIns="0" bIns="0" anchor="t">
             <a:spAutoFit/>
           </a:bodyPr>
           <a:lstStyle/>
@@ -4698,11 +4733,23 @@
   <p:clrMapOvr>
     <a:masterClrMapping/>
   </p:clrMapOvr>
+  <mc:AlternateContent xmlns:mc="http://schemas.openxmlformats.org/markup-compatibility/2006">
+    <mc:Choice xmlns:p159="http://schemas.microsoft.com/office/powerpoint/2015/09/main" Requires="p159">
+      <p:transition xmlns:p14="http://schemas.microsoft.com/office/powerpoint/2010/main" spd="slow" p14:dur="2000">
+        <p159:morph option="byObject"/>
+      </p:transition>
+    </mc:Choice>
+    <mc:Fallback>
+      <p:transition spd="slow">
+        <p:fade/>
+      </p:transition>
+    </mc:Fallback>
+  </mc:AlternateContent>
 </p:sld>
 </file>
 
 <file path=ppt/slides/slide11.xml><?xml version="1.0" encoding="utf-8"?>
-<p:sld xmlns:a="http://schemas.openxmlformats.org/drawingml/2006/main" xmlns:p="http://schemas.openxmlformats.org/presentationml/2006/main" xmlns:r="http://schemas.openxmlformats.org/officeDocument/2006/relationships">
+<p:sld xmlns:a="http://schemas.openxmlformats.org/drawingml/2006/main" xmlns:r="http://schemas.openxmlformats.org/officeDocument/2006/relationships" xmlns:p="http://schemas.openxmlformats.org/presentationml/2006/main">
   <p:cSld>
     <p:spTree>
       <p:nvGrpSpPr>
@@ -4710,7 +4757,14 @@
         <p:cNvGrpSpPr/>
         <p:nvPr/>
       </p:nvGrpSpPr>
-      <p:grpSpPr/>
+      <p:grpSpPr>
+        <a:xfrm>
+          <a:off x="0" y="0"/>
+          <a:ext cx="0" cy="0"/>
+          <a:chOff x="0" y="0"/>
+          <a:chExt cx="0" cy="0"/>
+        </a:xfrm>
+      </p:grpSpPr>
       <p:sp>
         <p:nvSpPr>
           <p:cNvPr id="2" name="Rectangle 1"/>
@@ -4752,6 +4806,7 @@
           <a:lstStyle/>
           <a:p>
             <a:pPr algn="ctr"/>
+            <a:endParaRPr/>
           </a:p>
         </p:txBody>
       </p:sp>
@@ -4796,6 +4851,7 @@
           <a:lstStyle/>
           <a:p>
             <a:pPr algn="ctr"/>
+            <a:endParaRPr/>
           </a:p>
         </p:txBody>
       </p:sp>
@@ -4816,7 +4872,7 @@
           <a:noFill/>
         </p:spPr>
         <p:txBody>
-          <a:bodyPr wrap="square" anchor="t" lIns="0" rIns="0" tIns="0" bIns="0">
+          <a:bodyPr wrap="square" lIns="0" tIns="0" rIns="0" bIns="0" anchor="t">
             <a:spAutoFit/>
           </a:bodyPr>
           <a:lstStyle/>
@@ -4858,7 +4914,7 @@
           <a:noFill/>
         </p:spPr>
         <p:txBody>
-          <a:bodyPr wrap="square" anchor="t" lIns="0" rIns="0" tIns="0" bIns="0">
+          <a:bodyPr wrap="square" lIns="0" tIns="0" rIns="0" bIns="0" anchor="t">
             <a:spAutoFit/>
           </a:bodyPr>
           <a:lstStyle/>
@@ -4900,7 +4956,7 @@
           <a:noFill/>
         </p:spPr>
         <p:txBody>
-          <a:bodyPr wrap="square" anchor="t" lIns="0" rIns="0" tIns="0" bIns="0">
+          <a:bodyPr wrap="square" lIns="0" tIns="0" rIns="0" bIns="0" anchor="t">
             <a:spAutoFit/>
           </a:bodyPr>
           <a:lstStyle/>
@@ -4990,6 +5046,7 @@
           <a:lstStyle/>
           <a:p>
             <a:pPr algn="ctr"/>
+            <a:endParaRPr/>
           </a:p>
         </p:txBody>
       </p:sp>
@@ -5010,7 +5067,7 @@
           <a:noFill/>
         </p:spPr>
         <p:txBody>
-          <a:bodyPr wrap="square" anchor="t" lIns="0" rIns="0" tIns="0" bIns="0">
+          <a:bodyPr wrap="square" lIns="0" tIns="0" rIns="0" bIns="0" anchor="t">
             <a:spAutoFit/>
           </a:bodyPr>
           <a:lstStyle/>
@@ -5052,7 +5109,7 @@
           <a:noFill/>
         </p:spPr>
         <p:txBody>
-          <a:bodyPr wrap="square" anchor="t" lIns="0" rIns="0" tIns="0" bIns="0">
+          <a:bodyPr wrap="square" lIns="0" tIns="0" rIns="0" bIns="0" anchor="t">
             <a:spAutoFit/>
           </a:bodyPr>
           <a:lstStyle/>
@@ -5118,6 +5175,7 @@
           <a:lstStyle/>
           <a:p>
             <a:pPr algn="ctr"/>
+            <a:endParaRPr/>
           </a:p>
         </p:txBody>
       </p:sp>
@@ -5138,7 +5196,7 @@
           <a:noFill/>
         </p:spPr>
         <p:txBody>
-          <a:bodyPr wrap="square" anchor="t" lIns="0" rIns="0" tIns="0" bIns="0">
+          <a:bodyPr wrap="square" lIns="0" tIns="0" rIns="0" bIns="0" anchor="t">
             <a:spAutoFit/>
           </a:bodyPr>
           <a:lstStyle/>
@@ -5180,7 +5238,7 @@
           <a:noFill/>
         </p:spPr>
         <p:txBody>
-          <a:bodyPr wrap="square" anchor="t" lIns="0" rIns="0" tIns="0" bIns="0">
+          <a:bodyPr wrap="square" lIns="0" tIns="0" rIns="0" bIns="0" anchor="t">
             <a:spAutoFit/>
           </a:bodyPr>
           <a:lstStyle/>
@@ -5246,6 +5304,7 @@
           <a:lstStyle/>
           <a:p>
             <a:pPr algn="ctr"/>
+            <a:endParaRPr/>
           </a:p>
         </p:txBody>
       </p:sp>
@@ -5266,7 +5325,7 @@
           <a:noFill/>
         </p:spPr>
         <p:txBody>
-          <a:bodyPr wrap="square" anchor="t" lIns="0" rIns="0" tIns="0" bIns="0">
+          <a:bodyPr wrap="square" lIns="0" tIns="0" rIns="0" bIns="0" anchor="t">
             <a:spAutoFit/>
           </a:bodyPr>
           <a:lstStyle/>
@@ -5308,7 +5367,7 @@
           <a:noFill/>
         </p:spPr>
         <p:txBody>
-          <a:bodyPr wrap="square" anchor="t" lIns="0" rIns="0" tIns="0" bIns="0">
+          <a:bodyPr wrap="square" lIns="0" tIns="0" rIns="0" bIns="0" anchor="t">
             <a:spAutoFit/>
           </a:bodyPr>
           <a:lstStyle/>
@@ -5374,6 +5433,7 @@
           <a:lstStyle/>
           <a:p>
             <a:pPr algn="ctr"/>
+            <a:endParaRPr/>
           </a:p>
         </p:txBody>
       </p:sp>
@@ -5418,7 +5478,7 @@
           <a:noFill/>
         </p:spPr>
         <p:txBody>
-          <a:bodyPr wrap="square" anchor="t" lIns="0" rIns="0" tIns="0" bIns="0">
+          <a:bodyPr wrap="square" lIns="0" tIns="0" rIns="0" bIns="0" anchor="t">
             <a:spAutoFit/>
           </a:bodyPr>
           <a:lstStyle/>
@@ -5484,6 +5544,7 @@
           <a:lstStyle/>
           <a:p>
             <a:pPr algn="ctr"/>
+            <a:endParaRPr/>
           </a:p>
         </p:txBody>
       </p:sp>
@@ -5504,7 +5565,7 @@
           <a:noFill/>
         </p:spPr>
         <p:txBody>
-          <a:bodyPr wrap="square" anchor="t" lIns="0" rIns="0" tIns="0" bIns="0">
+          <a:bodyPr wrap="square" lIns="0" tIns="0" rIns="0" bIns="0" anchor="t">
             <a:spAutoFit/>
           </a:bodyPr>
           <a:lstStyle/>
@@ -5546,7 +5607,7 @@
           <a:noFill/>
         </p:spPr>
         <p:txBody>
-          <a:bodyPr wrap="square" anchor="t" lIns="0" rIns="0" tIns="0" bIns="0">
+          <a:bodyPr wrap="square" lIns="0" tIns="0" rIns="0" bIns="0" anchor="t">
             <a:spAutoFit/>
           </a:bodyPr>
           <a:lstStyle/>
@@ -5576,11 +5637,23 @@
   <p:clrMapOvr>
     <a:masterClrMapping/>
   </p:clrMapOvr>
+  <mc:AlternateContent xmlns:mc="http://schemas.openxmlformats.org/markup-compatibility/2006">
+    <mc:Choice xmlns:p159="http://schemas.microsoft.com/office/powerpoint/2015/09/main" Requires="p159">
+      <p:transition xmlns:p14="http://schemas.microsoft.com/office/powerpoint/2010/main" spd="slow" p14:dur="2000">
+        <p159:morph option="byObject"/>
+      </p:transition>
+    </mc:Choice>
+    <mc:Fallback>
+      <p:transition spd="slow">
+        <p:fade/>
+      </p:transition>
+    </mc:Fallback>
+  </mc:AlternateContent>
 </p:sld>
 </file>
 
 <file path=ppt/slides/slide12.xml><?xml version="1.0" encoding="utf-8"?>
-<p:sld xmlns:a="http://schemas.openxmlformats.org/drawingml/2006/main" xmlns:p="http://schemas.openxmlformats.org/presentationml/2006/main" xmlns:r="http://schemas.openxmlformats.org/officeDocument/2006/relationships">
+<p:sld xmlns:a="http://schemas.openxmlformats.org/drawingml/2006/main" xmlns:r="http://schemas.openxmlformats.org/officeDocument/2006/relationships" xmlns:p="http://schemas.openxmlformats.org/presentationml/2006/main">
   <p:cSld>
     <p:spTree>
       <p:nvGrpSpPr>
@@ -5588,7 +5661,14 @@
         <p:cNvGrpSpPr/>
         <p:nvPr/>
       </p:nvGrpSpPr>
-      <p:grpSpPr/>
+      <p:grpSpPr>
+        <a:xfrm>
+          <a:off x="0" y="0"/>
+          <a:ext cx="0" cy="0"/>
+          <a:chOff x="0" y="0"/>
+          <a:chExt cx="0" cy="0"/>
+        </a:xfrm>
+      </p:grpSpPr>
       <p:sp>
         <p:nvSpPr>
           <p:cNvPr id="2" name="Rectangle 1"/>
@@ -5630,6 +5710,7 @@
           <a:lstStyle/>
           <a:p>
             <a:pPr algn="ctr"/>
+            <a:endParaRPr/>
           </a:p>
         </p:txBody>
       </p:sp>
@@ -5674,6 +5755,7 @@
           <a:lstStyle/>
           <a:p>
             <a:pPr algn="ctr"/>
+            <a:endParaRPr/>
           </a:p>
         </p:txBody>
       </p:sp>
@@ -5694,7 +5776,7 @@
           <a:noFill/>
         </p:spPr>
         <p:txBody>
-          <a:bodyPr wrap="square" anchor="t" lIns="0" rIns="0" tIns="0" bIns="0">
+          <a:bodyPr wrap="square" lIns="0" tIns="0" rIns="0" bIns="0" anchor="t">
             <a:spAutoFit/>
           </a:bodyPr>
           <a:lstStyle/>
@@ -5736,7 +5818,7 @@
           <a:noFill/>
         </p:spPr>
         <p:txBody>
-          <a:bodyPr wrap="square" anchor="t" lIns="0" rIns="0" tIns="0" bIns="0">
+          <a:bodyPr wrap="square" lIns="0" tIns="0" rIns="0" bIns="0" anchor="t">
             <a:spAutoFit/>
           </a:bodyPr>
           <a:lstStyle/>
@@ -5778,7 +5860,7 @@
           <a:noFill/>
         </p:spPr>
         <p:txBody>
-          <a:bodyPr wrap="square" anchor="t" lIns="0" rIns="0" tIns="0" bIns="0">
+          <a:bodyPr wrap="square" lIns="0" tIns="0" rIns="0" bIns="0" anchor="t">
             <a:spAutoFit/>
           </a:bodyPr>
           <a:lstStyle/>
@@ -5868,6 +5950,7 @@
           <a:lstStyle/>
           <a:p>
             <a:pPr algn="ctr"/>
+            <a:endParaRPr/>
           </a:p>
         </p:txBody>
       </p:sp>
@@ -5888,7 +5971,7 @@
           <a:noFill/>
         </p:spPr>
         <p:txBody>
-          <a:bodyPr wrap="square" anchor="t" lIns="0" rIns="0" tIns="0" bIns="0">
+          <a:bodyPr wrap="square" lIns="0" tIns="0" rIns="0" bIns="0" anchor="t">
             <a:spAutoFit/>
           </a:bodyPr>
           <a:lstStyle/>
@@ -5930,7 +6013,7 @@
           <a:noFill/>
         </p:spPr>
         <p:txBody>
-          <a:bodyPr wrap="square" anchor="t" lIns="0" rIns="0" tIns="0" bIns="0">
+          <a:bodyPr wrap="square" lIns="0" tIns="0" rIns="0" bIns="0" anchor="t">
             <a:spAutoFit/>
           </a:bodyPr>
           <a:lstStyle/>
@@ -5972,7 +6055,7 @@
           <a:noFill/>
         </p:spPr>
         <p:txBody>
-          <a:bodyPr wrap="square" anchor="t" lIns="0" rIns="0" tIns="0" bIns="0">
+          <a:bodyPr wrap="square" lIns="0" tIns="0" rIns="0" bIns="0" anchor="t">
             <a:spAutoFit/>
           </a:bodyPr>
           <a:lstStyle/>
@@ -6038,6 +6121,7 @@
           <a:lstStyle/>
           <a:p>
             <a:pPr algn="ctr"/>
+            <a:endParaRPr/>
           </a:p>
         </p:txBody>
       </p:sp>
@@ -6058,7 +6142,7 @@
           <a:noFill/>
         </p:spPr>
         <p:txBody>
-          <a:bodyPr wrap="square" anchor="t" lIns="0" rIns="0" tIns="0" bIns="0">
+          <a:bodyPr wrap="square" lIns="0" tIns="0" rIns="0" bIns="0" anchor="t">
             <a:spAutoFit/>
           </a:bodyPr>
           <a:lstStyle/>
@@ -6100,7 +6184,7 @@
           <a:noFill/>
         </p:spPr>
         <p:txBody>
-          <a:bodyPr wrap="square" anchor="t" lIns="0" rIns="0" tIns="0" bIns="0">
+          <a:bodyPr wrap="square" lIns="0" tIns="0" rIns="0" bIns="0" anchor="t">
             <a:spAutoFit/>
           </a:bodyPr>
           <a:lstStyle/>
@@ -6142,7 +6226,7 @@
           <a:noFill/>
         </p:spPr>
         <p:txBody>
-          <a:bodyPr wrap="square" anchor="t" lIns="0" rIns="0" tIns="0" bIns="0">
+          <a:bodyPr wrap="square" lIns="0" tIns="0" rIns="0" bIns="0" anchor="t">
             <a:spAutoFit/>
           </a:bodyPr>
           <a:lstStyle/>
@@ -6184,7 +6268,7 @@
           <a:noFill/>
         </p:spPr>
         <p:txBody>
-          <a:bodyPr wrap="square" anchor="t" lIns="0" rIns="0" tIns="0" bIns="0">
+          <a:bodyPr wrap="square" lIns="0" tIns="0" rIns="0" bIns="0" anchor="t">
             <a:spAutoFit/>
           </a:bodyPr>
           <a:lstStyle/>
@@ -6226,7 +6310,7 @@
           <a:noFill/>
         </p:spPr>
         <p:txBody>
-          <a:bodyPr wrap="square" anchor="t" lIns="0" rIns="0" tIns="0" bIns="0">
+          <a:bodyPr wrap="square" lIns="0" tIns="0" rIns="0" bIns="0" anchor="t">
             <a:spAutoFit/>
           </a:bodyPr>
           <a:lstStyle/>
@@ -6268,7 +6352,7 @@
           <a:noFill/>
         </p:spPr>
         <p:txBody>
-          <a:bodyPr wrap="square" anchor="t" lIns="0" rIns="0" tIns="0" bIns="0">
+          <a:bodyPr wrap="square" lIns="0" tIns="0" rIns="0" bIns="0" anchor="t">
             <a:spAutoFit/>
           </a:bodyPr>
           <a:lstStyle/>
@@ -6334,6 +6418,7 @@
           <a:lstStyle/>
           <a:p>
             <a:pPr algn="ctr"/>
+            <a:endParaRPr/>
           </a:p>
         </p:txBody>
       </p:sp>
@@ -6354,7 +6439,7 @@
           <a:noFill/>
         </p:spPr>
         <p:txBody>
-          <a:bodyPr wrap="square" anchor="t" lIns="0" rIns="0" tIns="0" bIns="0">
+          <a:bodyPr wrap="square" lIns="0" tIns="0" rIns="0" bIns="0" anchor="t">
             <a:spAutoFit/>
           </a:bodyPr>
           <a:lstStyle/>
@@ -6396,7 +6481,7 @@
           <a:noFill/>
         </p:spPr>
         <p:txBody>
-          <a:bodyPr wrap="square" anchor="t" lIns="0" rIns="0" tIns="0" bIns="0">
+          <a:bodyPr wrap="square" lIns="0" tIns="0" rIns="0" bIns="0" anchor="t">
             <a:spAutoFit/>
           </a:bodyPr>
           <a:lstStyle/>
@@ -6438,7 +6523,7 @@
           <a:noFill/>
         </p:spPr>
         <p:txBody>
-          <a:bodyPr wrap="square" anchor="t" lIns="0" rIns="0" tIns="0" bIns="0">
+          <a:bodyPr wrap="square" lIns="0" tIns="0" rIns="0" bIns="0" anchor="t">
             <a:spAutoFit/>
           </a:bodyPr>
           <a:lstStyle/>
@@ -6480,7 +6565,7 @@
           <a:noFill/>
         </p:spPr>
         <p:txBody>
-          <a:bodyPr wrap="square" anchor="t" lIns="0" rIns="0" tIns="0" bIns="0">
+          <a:bodyPr wrap="square" lIns="0" tIns="0" rIns="0" bIns="0" anchor="t">
             <a:spAutoFit/>
           </a:bodyPr>
           <a:lstStyle/>
@@ -6522,7 +6607,7 @@
           <a:noFill/>
         </p:spPr>
         <p:txBody>
-          <a:bodyPr wrap="square" anchor="t" lIns="0" rIns="0" tIns="0" bIns="0">
+          <a:bodyPr wrap="square" lIns="0" tIns="0" rIns="0" bIns="0" anchor="t">
             <a:spAutoFit/>
           </a:bodyPr>
           <a:lstStyle/>
@@ -6564,7 +6649,7 @@
           <a:noFill/>
         </p:spPr>
         <p:txBody>
-          <a:bodyPr wrap="square" anchor="t" lIns="0" rIns="0" tIns="0" bIns="0">
+          <a:bodyPr wrap="square" lIns="0" tIns="0" rIns="0" bIns="0" anchor="t">
             <a:spAutoFit/>
           </a:bodyPr>
           <a:lstStyle/>
@@ -6630,6 +6715,7 @@
           <a:lstStyle/>
           <a:p>
             <a:pPr algn="ctr"/>
+            <a:endParaRPr/>
           </a:p>
         </p:txBody>
       </p:sp>
@@ -6650,7 +6736,7 @@
           <a:noFill/>
         </p:spPr>
         <p:txBody>
-          <a:bodyPr wrap="square" anchor="t" lIns="0" rIns="0" tIns="0" bIns="0">
+          <a:bodyPr wrap="square" lIns="0" tIns="0" rIns="0" bIns="0" anchor="t">
             <a:spAutoFit/>
           </a:bodyPr>
           <a:lstStyle/>
@@ -6692,7 +6778,7 @@
           <a:noFill/>
         </p:spPr>
         <p:txBody>
-          <a:bodyPr wrap="square" anchor="t" lIns="0" rIns="0" tIns="0" bIns="0">
+          <a:bodyPr wrap="square" lIns="0" tIns="0" rIns="0" bIns="0" anchor="t">
             <a:spAutoFit/>
           </a:bodyPr>
           <a:lstStyle/>
@@ -6734,7 +6820,7 @@
           <a:noFill/>
         </p:spPr>
         <p:txBody>
-          <a:bodyPr wrap="square" anchor="t" lIns="0" rIns="0" tIns="0" bIns="0">
+          <a:bodyPr wrap="square" lIns="0" tIns="0" rIns="0" bIns="0" anchor="t">
             <a:spAutoFit/>
           </a:bodyPr>
           <a:lstStyle/>
@@ -6776,7 +6862,7 @@
           <a:noFill/>
         </p:spPr>
         <p:txBody>
-          <a:bodyPr wrap="square" anchor="t" lIns="0" rIns="0" tIns="0" bIns="0">
+          <a:bodyPr wrap="square" lIns="0" tIns="0" rIns="0" bIns="0" anchor="t">
             <a:spAutoFit/>
           </a:bodyPr>
           <a:lstStyle/>
@@ -6818,7 +6904,7 @@
           <a:noFill/>
         </p:spPr>
         <p:txBody>
-          <a:bodyPr wrap="square" anchor="t" lIns="0" rIns="0" tIns="0" bIns="0">
+          <a:bodyPr wrap="square" lIns="0" tIns="0" rIns="0" bIns="0" anchor="t">
             <a:spAutoFit/>
           </a:bodyPr>
           <a:lstStyle/>
@@ -6860,7 +6946,7 @@
           <a:noFill/>
         </p:spPr>
         <p:txBody>
-          <a:bodyPr wrap="square" anchor="t" lIns="0" rIns="0" tIns="0" bIns="0">
+          <a:bodyPr wrap="square" lIns="0" tIns="0" rIns="0" bIns="0" anchor="t">
             <a:spAutoFit/>
           </a:bodyPr>
           <a:lstStyle/>
@@ -6926,6 +7012,7 @@
           <a:lstStyle/>
           <a:p>
             <a:pPr algn="ctr"/>
+            <a:endParaRPr/>
           </a:p>
         </p:txBody>
       </p:sp>
@@ -6946,7 +7033,7 @@
           <a:noFill/>
         </p:spPr>
         <p:txBody>
-          <a:bodyPr wrap="square" anchor="t" lIns="0" rIns="0" tIns="0" bIns="0">
+          <a:bodyPr wrap="square" lIns="0" tIns="0" rIns="0" bIns="0" anchor="t">
             <a:spAutoFit/>
           </a:bodyPr>
           <a:lstStyle/>
@@ -6988,7 +7075,7 @@
           <a:noFill/>
         </p:spPr>
         <p:txBody>
-          <a:bodyPr wrap="square" anchor="t" lIns="0" rIns="0" tIns="0" bIns="0">
+          <a:bodyPr wrap="square" lIns="0" tIns="0" rIns="0" bIns="0" anchor="t">
             <a:spAutoFit/>
           </a:bodyPr>
           <a:lstStyle/>
@@ -7030,7 +7117,7 @@
           <a:noFill/>
         </p:spPr>
         <p:txBody>
-          <a:bodyPr wrap="square" anchor="t" lIns="0" rIns="0" tIns="0" bIns="0">
+          <a:bodyPr wrap="square" lIns="0" tIns="0" rIns="0" bIns="0" anchor="t">
             <a:spAutoFit/>
           </a:bodyPr>
           <a:lstStyle/>
@@ -7072,7 +7159,7 @@
           <a:noFill/>
         </p:spPr>
         <p:txBody>
-          <a:bodyPr wrap="square" anchor="t" lIns="0" rIns="0" tIns="0" bIns="0">
+          <a:bodyPr wrap="square" lIns="0" tIns="0" rIns="0" bIns="0" anchor="t">
             <a:spAutoFit/>
           </a:bodyPr>
           <a:lstStyle/>
@@ -7114,7 +7201,7 @@
           <a:noFill/>
         </p:spPr>
         <p:txBody>
-          <a:bodyPr wrap="square" anchor="t" lIns="0" rIns="0" tIns="0" bIns="0">
+          <a:bodyPr wrap="square" lIns="0" tIns="0" rIns="0" bIns="0" anchor="t">
             <a:spAutoFit/>
           </a:bodyPr>
           <a:lstStyle/>
@@ -7156,7 +7243,7 @@
           <a:noFill/>
         </p:spPr>
         <p:txBody>
-          <a:bodyPr wrap="square" anchor="t" lIns="0" rIns="0" tIns="0" bIns="0">
+          <a:bodyPr wrap="square" lIns="0" tIns="0" rIns="0" bIns="0" anchor="t">
             <a:spAutoFit/>
           </a:bodyPr>
           <a:lstStyle/>
@@ -7222,6 +7309,7 @@
           <a:lstStyle/>
           <a:p>
             <a:pPr algn="ctr"/>
+            <a:endParaRPr/>
           </a:p>
         </p:txBody>
       </p:sp>
@@ -7242,7 +7330,7 @@
           <a:noFill/>
         </p:spPr>
         <p:txBody>
-          <a:bodyPr wrap="square" anchor="t" lIns="0" rIns="0" tIns="0" bIns="0">
+          <a:bodyPr wrap="square" lIns="0" tIns="0" rIns="0" bIns="0" anchor="t">
             <a:spAutoFit/>
           </a:bodyPr>
           <a:lstStyle/>
@@ -7284,7 +7372,7 @@
           <a:noFill/>
         </p:spPr>
         <p:txBody>
-          <a:bodyPr wrap="square" anchor="t" lIns="0" rIns="0" tIns="0" bIns="0">
+          <a:bodyPr wrap="square" lIns="0" tIns="0" rIns="0" bIns="0" anchor="t">
             <a:spAutoFit/>
           </a:bodyPr>
           <a:lstStyle/>
@@ -7326,7 +7414,7 @@
           <a:noFill/>
         </p:spPr>
         <p:txBody>
-          <a:bodyPr wrap="square" anchor="t" lIns="0" rIns="0" tIns="0" bIns="0">
+          <a:bodyPr wrap="square" lIns="0" tIns="0" rIns="0" bIns="0" anchor="t">
             <a:spAutoFit/>
           </a:bodyPr>
           <a:lstStyle/>
@@ -7368,7 +7456,7 @@
           <a:noFill/>
         </p:spPr>
         <p:txBody>
-          <a:bodyPr wrap="square" anchor="t" lIns="0" rIns="0" tIns="0" bIns="0">
+          <a:bodyPr wrap="square" lIns="0" tIns="0" rIns="0" bIns="0" anchor="t">
             <a:spAutoFit/>
           </a:bodyPr>
           <a:lstStyle/>
@@ -7410,7 +7498,7 @@
           <a:noFill/>
         </p:spPr>
         <p:txBody>
-          <a:bodyPr wrap="square" anchor="t" lIns="0" rIns="0" tIns="0" bIns="0">
+          <a:bodyPr wrap="square" lIns="0" tIns="0" rIns="0" bIns="0" anchor="t">
             <a:spAutoFit/>
           </a:bodyPr>
           <a:lstStyle/>
@@ -7452,7 +7540,7 @@
           <a:noFill/>
         </p:spPr>
         <p:txBody>
-          <a:bodyPr wrap="square" anchor="t" lIns="0" rIns="0" tIns="0" bIns="0">
+          <a:bodyPr wrap="square" lIns="0" tIns="0" rIns="0" bIns="0" anchor="t">
             <a:spAutoFit/>
           </a:bodyPr>
           <a:lstStyle/>
@@ -7518,6 +7606,7 @@
           <a:lstStyle/>
           <a:p>
             <a:pPr algn="ctr"/>
+            <a:endParaRPr/>
           </a:p>
         </p:txBody>
       </p:sp>
@@ -7538,7 +7627,7 @@
           <a:noFill/>
         </p:spPr>
         <p:txBody>
-          <a:bodyPr wrap="square" anchor="t" lIns="0" rIns="0" tIns="0" bIns="0">
+          <a:bodyPr wrap="square" lIns="0" tIns="0" rIns="0" bIns="0" anchor="t">
             <a:spAutoFit/>
           </a:bodyPr>
           <a:lstStyle/>
@@ -7580,7 +7669,7 @@
           <a:noFill/>
         </p:spPr>
         <p:txBody>
-          <a:bodyPr wrap="square" anchor="t" lIns="0" rIns="0" tIns="0" bIns="0">
+          <a:bodyPr wrap="square" lIns="0" tIns="0" rIns="0" bIns="0" anchor="t">
             <a:spAutoFit/>
           </a:bodyPr>
           <a:lstStyle/>
@@ -7622,7 +7711,7 @@
           <a:noFill/>
         </p:spPr>
         <p:txBody>
-          <a:bodyPr wrap="square" anchor="t" lIns="0" rIns="0" tIns="0" bIns="0">
+          <a:bodyPr wrap="square" lIns="0" tIns="0" rIns="0" bIns="0" anchor="t">
             <a:spAutoFit/>
           </a:bodyPr>
           <a:lstStyle/>
@@ -7664,7 +7753,7 @@
           <a:noFill/>
         </p:spPr>
         <p:txBody>
-          <a:bodyPr wrap="square" anchor="t" lIns="0" rIns="0" tIns="0" bIns="0">
+          <a:bodyPr wrap="square" lIns="0" tIns="0" rIns="0" bIns="0" anchor="t">
             <a:spAutoFit/>
           </a:bodyPr>
           <a:lstStyle/>
@@ -7706,7 +7795,7 @@
           <a:noFill/>
         </p:spPr>
         <p:txBody>
-          <a:bodyPr wrap="square" anchor="t" lIns="0" rIns="0" tIns="0" bIns="0">
+          <a:bodyPr wrap="square" lIns="0" tIns="0" rIns="0" bIns="0" anchor="t">
             <a:spAutoFit/>
           </a:bodyPr>
           <a:lstStyle/>
@@ -7772,6 +7861,7 @@
           <a:lstStyle/>
           <a:p>
             <a:pPr algn="ctr"/>
+            <a:endParaRPr/>
           </a:p>
         </p:txBody>
       </p:sp>
@@ -7792,7 +7882,7 @@
           <a:noFill/>
         </p:spPr>
         <p:txBody>
-          <a:bodyPr wrap="square" anchor="t" lIns="0" rIns="0" tIns="0" bIns="0">
+          <a:bodyPr wrap="square" lIns="0" tIns="0" rIns="0" bIns="0" anchor="t">
             <a:spAutoFit/>
           </a:bodyPr>
           <a:lstStyle/>
@@ -7834,7 +7924,7 @@
           <a:noFill/>
         </p:spPr>
         <p:txBody>
-          <a:bodyPr wrap="square" anchor="t" lIns="0" rIns="0" tIns="0" bIns="0">
+          <a:bodyPr wrap="square" lIns="0" tIns="0" rIns="0" bIns="0" anchor="t">
             <a:spAutoFit/>
           </a:bodyPr>
           <a:lstStyle/>
@@ -7864,11 +7954,23 @@
   <p:clrMapOvr>
     <a:masterClrMapping/>
   </p:clrMapOvr>
+  <mc:AlternateContent xmlns:mc="http://schemas.openxmlformats.org/markup-compatibility/2006">
+    <mc:Choice xmlns:p159="http://schemas.microsoft.com/office/powerpoint/2015/09/main" Requires="p159">
+      <p:transition xmlns:p14="http://schemas.microsoft.com/office/powerpoint/2010/main" spd="slow" p14:dur="2000">
+        <p159:morph option="byObject"/>
+      </p:transition>
+    </mc:Choice>
+    <mc:Fallback>
+      <p:transition spd="slow">
+        <p:fade/>
+      </p:transition>
+    </mc:Fallback>
+  </mc:AlternateContent>
 </p:sld>
 </file>
 
 <file path=ppt/slides/slide13.xml><?xml version="1.0" encoding="utf-8"?>
-<p:sld xmlns:a="http://schemas.openxmlformats.org/drawingml/2006/main" xmlns:p="http://schemas.openxmlformats.org/presentationml/2006/main" xmlns:r="http://schemas.openxmlformats.org/officeDocument/2006/relationships">
+<p:sld xmlns:a="http://schemas.openxmlformats.org/drawingml/2006/main" xmlns:r="http://schemas.openxmlformats.org/officeDocument/2006/relationships" xmlns:p="http://schemas.openxmlformats.org/presentationml/2006/main">
   <p:cSld>
     <p:spTree>
       <p:nvGrpSpPr>
@@ -7876,7 +7978,14 @@
         <p:cNvGrpSpPr/>
         <p:nvPr/>
       </p:nvGrpSpPr>
-      <p:grpSpPr/>
+      <p:grpSpPr>
+        <a:xfrm>
+          <a:off x="0" y="0"/>
+          <a:ext cx="0" cy="0"/>
+          <a:chOff x="0" y="0"/>
+          <a:chExt cx="0" cy="0"/>
+        </a:xfrm>
+      </p:grpSpPr>
       <p:sp>
         <p:nvSpPr>
           <p:cNvPr id="2" name="Rectangle 1"/>
@@ -7918,6 +8027,7 @@
           <a:lstStyle/>
           <a:p>
             <a:pPr algn="ctr"/>
+            <a:endParaRPr/>
           </a:p>
         </p:txBody>
       </p:sp>
@@ -7962,6 +8072,7 @@
           <a:lstStyle/>
           <a:p>
             <a:pPr algn="ctr"/>
+            <a:endParaRPr/>
           </a:p>
         </p:txBody>
       </p:sp>
@@ -7982,7 +8093,7 @@
           <a:noFill/>
         </p:spPr>
         <p:txBody>
-          <a:bodyPr wrap="square" anchor="t" lIns="0" rIns="0" tIns="0" bIns="0">
+          <a:bodyPr wrap="square" lIns="0" tIns="0" rIns="0" bIns="0" anchor="t">
             <a:spAutoFit/>
           </a:bodyPr>
           <a:lstStyle/>
@@ -8024,7 +8135,7 @@
           <a:noFill/>
         </p:spPr>
         <p:txBody>
-          <a:bodyPr wrap="square" anchor="t" lIns="0" rIns="0" tIns="0" bIns="0">
+          <a:bodyPr wrap="square" lIns="0" tIns="0" rIns="0" bIns="0" anchor="t">
             <a:spAutoFit/>
           </a:bodyPr>
           <a:lstStyle/>
@@ -8066,7 +8177,7 @@
           <a:noFill/>
         </p:spPr>
         <p:txBody>
-          <a:bodyPr wrap="square" anchor="t" lIns="0" rIns="0" tIns="0" bIns="0">
+          <a:bodyPr wrap="square" lIns="0" tIns="0" rIns="0" bIns="0" anchor="t">
             <a:spAutoFit/>
           </a:bodyPr>
           <a:lstStyle/>
@@ -8132,7 +8243,7 @@
           <a:noFill/>
         </p:spPr>
         <p:txBody>
-          <a:bodyPr wrap="square" anchor="t" lIns="0" rIns="0" tIns="0" bIns="0">
+          <a:bodyPr wrap="square" lIns="0" tIns="0" rIns="0" bIns="0" anchor="t">
             <a:spAutoFit/>
           </a:bodyPr>
           <a:lstStyle/>
@@ -8174,7 +8285,7 @@
           <a:noFill/>
         </p:spPr>
         <p:txBody>
-          <a:bodyPr wrap="square" anchor="t" lIns="0" rIns="0" tIns="0" bIns="0">
+          <a:bodyPr wrap="square" lIns="0" tIns="0" rIns="0" bIns="0" anchor="t">
             <a:spAutoFit/>
           </a:bodyPr>
           <a:lstStyle/>
@@ -8240,6 +8351,7 @@
           <a:lstStyle/>
           <a:p>
             <a:pPr algn="ctr"/>
+            <a:endParaRPr/>
           </a:p>
         </p:txBody>
       </p:sp>
@@ -8260,7 +8372,7 @@
           <a:noFill/>
         </p:spPr>
         <p:txBody>
-          <a:bodyPr wrap="square" anchor="t" lIns="0" rIns="0" tIns="0" bIns="0">
+          <a:bodyPr wrap="square" lIns="0" tIns="0" rIns="0" bIns="0" anchor="t">
             <a:spAutoFit/>
           </a:bodyPr>
           <a:lstStyle/>
@@ -8326,6 +8438,7 @@
           <a:lstStyle/>
           <a:p>
             <a:pPr algn="ctr"/>
+            <a:endParaRPr/>
           </a:p>
         </p:txBody>
       </p:sp>
@@ -8346,7 +8459,7 @@
           <a:noFill/>
         </p:spPr>
         <p:txBody>
-          <a:bodyPr wrap="square" anchor="t" lIns="0" rIns="0" tIns="0" bIns="0">
+          <a:bodyPr wrap="square" lIns="0" tIns="0" rIns="0" bIns="0" anchor="t">
             <a:spAutoFit/>
           </a:bodyPr>
           <a:lstStyle/>
@@ -8388,7 +8501,7 @@
           <a:noFill/>
         </p:spPr>
         <p:txBody>
-          <a:bodyPr wrap="square" anchor="t" lIns="0" rIns="0" tIns="0" bIns="0">
+          <a:bodyPr wrap="square" lIns="0" tIns="0" rIns="0" bIns="0" anchor="t">
             <a:spAutoFit/>
           </a:bodyPr>
           <a:lstStyle/>
@@ -8454,6 +8567,7 @@
           <a:lstStyle/>
           <a:p>
             <a:pPr algn="ctr"/>
+            <a:endParaRPr/>
           </a:p>
         </p:txBody>
       </p:sp>
@@ -8474,7 +8588,7 @@
           <a:noFill/>
         </p:spPr>
         <p:txBody>
-          <a:bodyPr wrap="square" anchor="t" lIns="0" rIns="0" tIns="0" bIns="0">
+          <a:bodyPr wrap="square" lIns="0" tIns="0" rIns="0" bIns="0" anchor="t">
             <a:spAutoFit/>
           </a:bodyPr>
           <a:lstStyle/>
@@ -8540,6 +8654,7 @@
           <a:lstStyle/>
           <a:p>
             <a:pPr algn="ctr"/>
+            <a:endParaRPr/>
           </a:p>
         </p:txBody>
       </p:sp>
@@ -8560,7 +8675,7 @@
           <a:noFill/>
         </p:spPr>
         <p:txBody>
-          <a:bodyPr wrap="square" anchor="t" lIns="0" rIns="0" tIns="0" bIns="0">
+          <a:bodyPr wrap="square" lIns="0" tIns="0" rIns="0" bIns="0" anchor="t">
             <a:spAutoFit/>
           </a:bodyPr>
           <a:lstStyle/>
@@ -8602,7 +8717,7 @@
           <a:noFill/>
         </p:spPr>
         <p:txBody>
-          <a:bodyPr wrap="square" anchor="t" lIns="0" rIns="0" tIns="0" bIns="0">
+          <a:bodyPr wrap="square" lIns="0" tIns="0" rIns="0" bIns="0" anchor="t">
             <a:spAutoFit/>
           </a:bodyPr>
           <a:lstStyle/>
@@ -8668,6 +8783,7 @@
           <a:lstStyle/>
           <a:p>
             <a:pPr algn="ctr"/>
+            <a:endParaRPr/>
           </a:p>
         </p:txBody>
       </p:sp>
@@ -8688,7 +8804,7 @@
           <a:noFill/>
         </p:spPr>
         <p:txBody>
-          <a:bodyPr wrap="square" anchor="t" lIns="0" rIns="0" tIns="0" bIns="0">
+          <a:bodyPr wrap="square" lIns="0" tIns="0" rIns="0" bIns="0" anchor="t">
             <a:spAutoFit/>
           </a:bodyPr>
           <a:lstStyle/>
@@ -8754,6 +8870,7 @@
           <a:lstStyle/>
           <a:p>
             <a:pPr algn="ctr"/>
+            <a:endParaRPr/>
           </a:p>
         </p:txBody>
       </p:sp>
@@ -8774,7 +8891,7 @@
           <a:noFill/>
         </p:spPr>
         <p:txBody>
-          <a:bodyPr wrap="square" anchor="t" lIns="0" rIns="0" tIns="0" bIns="0">
+          <a:bodyPr wrap="square" lIns="0" tIns="0" rIns="0" bIns="0" anchor="t">
             <a:spAutoFit/>
           </a:bodyPr>
           <a:lstStyle/>
@@ -8816,7 +8933,7 @@
           <a:noFill/>
         </p:spPr>
         <p:txBody>
-          <a:bodyPr wrap="square" anchor="t" lIns="0" rIns="0" tIns="0" bIns="0">
+          <a:bodyPr wrap="square" lIns="0" tIns="0" rIns="0" bIns="0" anchor="t">
             <a:spAutoFit/>
           </a:bodyPr>
           <a:lstStyle/>
@@ -8882,6 +8999,7 @@
           <a:lstStyle/>
           <a:p>
             <a:pPr algn="ctr"/>
+            <a:endParaRPr/>
           </a:p>
         </p:txBody>
       </p:sp>
@@ -8902,7 +9020,7 @@
           <a:noFill/>
         </p:spPr>
         <p:txBody>
-          <a:bodyPr wrap="square" anchor="t" lIns="0" rIns="0" tIns="0" bIns="0">
+          <a:bodyPr wrap="square" lIns="0" tIns="0" rIns="0" bIns="0" anchor="t">
             <a:spAutoFit/>
           </a:bodyPr>
           <a:lstStyle/>
@@ -8968,6 +9086,7 @@
           <a:lstStyle/>
           <a:p>
             <a:pPr algn="ctr"/>
+            <a:endParaRPr/>
           </a:p>
         </p:txBody>
       </p:sp>
@@ -8988,7 +9107,7 @@
           <a:noFill/>
         </p:spPr>
         <p:txBody>
-          <a:bodyPr wrap="square" anchor="t" lIns="0" rIns="0" tIns="0" bIns="0">
+          <a:bodyPr wrap="square" lIns="0" tIns="0" rIns="0" bIns="0" anchor="t">
             <a:spAutoFit/>
           </a:bodyPr>
           <a:lstStyle/>
@@ -9030,7 +9149,7 @@
           <a:noFill/>
         </p:spPr>
         <p:txBody>
-          <a:bodyPr wrap="square" anchor="t" lIns="0" rIns="0" tIns="0" bIns="0">
+          <a:bodyPr wrap="square" lIns="0" tIns="0" rIns="0" bIns="0" anchor="t">
             <a:spAutoFit/>
           </a:bodyPr>
           <a:lstStyle/>
@@ -9096,6 +9215,7 @@
           <a:lstStyle/>
           <a:p>
             <a:pPr algn="ctr"/>
+            <a:endParaRPr/>
           </a:p>
         </p:txBody>
       </p:sp>
@@ -9116,7 +9236,7 @@
           <a:noFill/>
         </p:spPr>
         <p:txBody>
-          <a:bodyPr wrap="square" anchor="t" lIns="0" rIns="0" tIns="0" bIns="0">
+          <a:bodyPr wrap="square" lIns="0" tIns="0" rIns="0" bIns="0" anchor="t">
             <a:spAutoFit/>
           </a:bodyPr>
           <a:lstStyle/>
@@ -9182,6 +9302,7 @@
           <a:lstStyle/>
           <a:p>
             <a:pPr algn="ctr"/>
+            <a:endParaRPr/>
           </a:p>
         </p:txBody>
       </p:sp>
@@ -9202,7 +9323,7 @@
           <a:noFill/>
         </p:spPr>
         <p:txBody>
-          <a:bodyPr wrap="square" anchor="t" lIns="0" rIns="0" tIns="0" bIns="0">
+          <a:bodyPr wrap="square" lIns="0" tIns="0" rIns="0" bIns="0" anchor="t">
             <a:spAutoFit/>
           </a:bodyPr>
           <a:lstStyle/>
@@ -9244,7 +9365,7 @@
           <a:noFill/>
         </p:spPr>
         <p:txBody>
-          <a:bodyPr wrap="square" anchor="t" lIns="0" rIns="0" tIns="0" bIns="0">
+          <a:bodyPr wrap="square" lIns="0" tIns="0" rIns="0" bIns="0" anchor="t">
             <a:spAutoFit/>
           </a:bodyPr>
           <a:lstStyle/>
@@ -9310,6 +9431,7 @@
           <a:lstStyle/>
           <a:p>
             <a:pPr algn="ctr"/>
+            <a:endParaRPr/>
           </a:p>
         </p:txBody>
       </p:sp>
@@ -9330,7 +9452,7 @@
           <a:noFill/>
         </p:spPr>
         <p:txBody>
-          <a:bodyPr wrap="square" anchor="t" lIns="0" rIns="0" tIns="0" bIns="0">
+          <a:bodyPr wrap="square" lIns="0" tIns="0" rIns="0" bIns="0" anchor="t">
             <a:spAutoFit/>
           </a:bodyPr>
           <a:lstStyle/>
@@ -9396,6 +9518,7 @@
           <a:lstStyle/>
           <a:p>
             <a:pPr algn="ctr"/>
+            <a:endParaRPr/>
           </a:p>
         </p:txBody>
       </p:sp>
@@ -9416,7 +9539,7 @@
           <a:noFill/>
         </p:spPr>
         <p:txBody>
-          <a:bodyPr wrap="square" anchor="t" lIns="0" rIns="0" tIns="0" bIns="0">
+          <a:bodyPr wrap="square" lIns="0" tIns="0" rIns="0" bIns="0" anchor="t">
             <a:spAutoFit/>
           </a:bodyPr>
           <a:lstStyle/>
@@ -9458,7 +9581,7 @@
           <a:noFill/>
         </p:spPr>
         <p:txBody>
-          <a:bodyPr wrap="square" anchor="t" lIns="0" rIns="0" tIns="0" bIns="0">
+          <a:bodyPr wrap="square" lIns="0" tIns="0" rIns="0" bIns="0" anchor="t">
             <a:spAutoFit/>
           </a:bodyPr>
           <a:lstStyle/>
@@ -9524,6 +9647,7 @@
           <a:lstStyle/>
           <a:p>
             <a:pPr algn="ctr"/>
+            <a:endParaRPr/>
           </a:p>
         </p:txBody>
       </p:sp>
@@ -9544,7 +9668,7 @@
           <a:noFill/>
         </p:spPr>
         <p:txBody>
-          <a:bodyPr wrap="square" anchor="t" lIns="0" rIns="0" tIns="0" bIns="0">
+          <a:bodyPr wrap="square" lIns="0" tIns="0" rIns="0" bIns="0" anchor="t">
             <a:spAutoFit/>
           </a:bodyPr>
           <a:lstStyle/>
@@ -9586,7 +9710,7 @@
           <a:noFill/>
         </p:spPr>
         <p:txBody>
-          <a:bodyPr wrap="square" anchor="t" lIns="0" rIns="0" tIns="0" bIns="0">
+          <a:bodyPr wrap="square" lIns="0" tIns="0" rIns="0" bIns="0" anchor="t">
             <a:spAutoFit/>
           </a:bodyPr>
           <a:lstStyle/>
@@ -9652,6 +9776,7 @@
           <a:lstStyle/>
           <a:p>
             <a:pPr algn="ctr"/>
+            <a:endParaRPr/>
           </a:p>
         </p:txBody>
       </p:sp>
@@ -9672,7 +9797,7 @@
           <a:noFill/>
         </p:spPr>
         <p:txBody>
-          <a:bodyPr wrap="square" anchor="t" lIns="0" rIns="0" tIns="0" bIns="0">
+          <a:bodyPr wrap="square" lIns="0" tIns="0" rIns="0" bIns="0" anchor="t">
             <a:spAutoFit/>
           </a:bodyPr>
           <a:lstStyle/>
@@ -9714,7 +9839,7 @@
           <a:noFill/>
         </p:spPr>
         <p:txBody>
-          <a:bodyPr wrap="square" anchor="t" lIns="0" rIns="0" tIns="0" bIns="0">
+          <a:bodyPr wrap="square" lIns="0" tIns="0" rIns="0" bIns="0" anchor="t">
             <a:spAutoFit/>
           </a:bodyPr>
           <a:lstStyle/>
@@ -9744,11 +9869,23 @@
   <p:clrMapOvr>
     <a:masterClrMapping/>
   </p:clrMapOvr>
+  <mc:AlternateContent xmlns:mc="http://schemas.openxmlformats.org/markup-compatibility/2006">
+    <mc:Choice xmlns:p159="http://schemas.microsoft.com/office/powerpoint/2015/09/main" Requires="p159">
+      <p:transition xmlns:p14="http://schemas.microsoft.com/office/powerpoint/2010/main" spd="slow" p14:dur="2000">
+        <p159:morph option="byObject"/>
+      </p:transition>
+    </mc:Choice>
+    <mc:Fallback>
+      <p:transition spd="slow">
+        <p:fade/>
+      </p:transition>
+    </mc:Fallback>
+  </mc:AlternateContent>
 </p:sld>
 </file>
 
 <file path=ppt/slides/slide14.xml><?xml version="1.0" encoding="utf-8"?>
-<p:sld xmlns:a="http://schemas.openxmlformats.org/drawingml/2006/main" xmlns:p="http://schemas.openxmlformats.org/presentationml/2006/main" xmlns:r="http://schemas.openxmlformats.org/officeDocument/2006/relationships">
+<p:sld xmlns:a="http://schemas.openxmlformats.org/drawingml/2006/main" xmlns:r="http://schemas.openxmlformats.org/officeDocument/2006/relationships" xmlns:p="http://schemas.openxmlformats.org/presentationml/2006/main">
   <p:cSld>
     <p:spTree>
       <p:nvGrpSpPr>
@@ -9756,7 +9893,14 @@
         <p:cNvGrpSpPr/>
         <p:nvPr/>
       </p:nvGrpSpPr>
-      <p:grpSpPr/>
+      <p:grpSpPr>
+        <a:xfrm>
+          <a:off x="0" y="0"/>
+          <a:ext cx="0" cy="0"/>
+          <a:chOff x="0" y="0"/>
+          <a:chExt cx="0" cy="0"/>
+        </a:xfrm>
+      </p:grpSpPr>
       <p:sp>
         <p:nvSpPr>
           <p:cNvPr id="2" name="Rectangle 1"/>
@@ -9798,6 +9942,7 @@
           <a:lstStyle/>
           <a:p>
             <a:pPr algn="ctr"/>
+            <a:endParaRPr/>
           </a:p>
         </p:txBody>
       </p:sp>
@@ -9842,6 +9987,7 @@
           <a:lstStyle/>
           <a:p>
             <a:pPr algn="ctr"/>
+            <a:endParaRPr/>
           </a:p>
         </p:txBody>
       </p:sp>
@@ -9862,7 +10008,7 @@
           <a:noFill/>
         </p:spPr>
         <p:txBody>
-          <a:bodyPr wrap="square" anchor="t" lIns="0" rIns="0" tIns="0" bIns="0">
+          <a:bodyPr wrap="square" lIns="0" tIns="0" rIns="0" bIns="0" anchor="t">
             <a:spAutoFit/>
           </a:bodyPr>
           <a:lstStyle/>
@@ -9904,7 +10050,7 @@
           <a:noFill/>
         </p:spPr>
         <p:txBody>
-          <a:bodyPr wrap="square" anchor="t" lIns="0" rIns="0" tIns="0" bIns="0">
+          <a:bodyPr wrap="square" lIns="0" tIns="0" rIns="0" bIns="0" anchor="t">
             <a:spAutoFit/>
           </a:bodyPr>
           <a:lstStyle/>
@@ -9994,6 +10140,7 @@
           <a:lstStyle/>
           <a:p>
             <a:pPr algn="ctr"/>
+            <a:endParaRPr/>
           </a:p>
         </p:txBody>
       </p:sp>
@@ -10014,7 +10161,7 @@
           <a:noFill/>
         </p:spPr>
         <p:txBody>
-          <a:bodyPr wrap="square" anchor="t" lIns="0" rIns="0" tIns="0" bIns="0">
+          <a:bodyPr wrap="square" lIns="0" tIns="0" rIns="0" bIns="0" anchor="t">
             <a:spAutoFit/>
           </a:bodyPr>
           <a:lstStyle/>
@@ -10056,7 +10203,7 @@
           <a:noFill/>
         </p:spPr>
         <p:txBody>
-          <a:bodyPr wrap="square" anchor="t" lIns="0" rIns="0" tIns="0" bIns="0">
+          <a:bodyPr wrap="square" lIns="0" tIns="0" rIns="0" bIns="0" anchor="t">
             <a:spAutoFit/>
           </a:bodyPr>
           <a:lstStyle/>
@@ -10099,7 +10246,7 @@
           <a:noFill/>
         </p:spPr>
         <p:txBody>
-          <a:bodyPr wrap="square" anchor="t" lIns="0" rIns="0" tIns="0" bIns="0">
+          <a:bodyPr wrap="square" lIns="0" tIns="0" rIns="0" bIns="0" anchor="t">
             <a:spAutoFit/>
           </a:bodyPr>
           <a:lstStyle/>
@@ -10141,7 +10288,7 @@
           <a:noFill/>
         </p:spPr>
         <p:txBody>
-          <a:bodyPr wrap="square" anchor="t" lIns="0" rIns="0" tIns="0" bIns="0">
+          <a:bodyPr wrap="square" lIns="0" tIns="0" rIns="0" bIns="0" anchor="t">
             <a:spAutoFit/>
           </a:bodyPr>
           <a:lstStyle/>
@@ -10184,7 +10331,7 @@
           <a:noFill/>
         </p:spPr>
         <p:txBody>
-          <a:bodyPr wrap="square" anchor="t" lIns="0" rIns="0" tIns="0" bIns="0">
+          <a:bodyPr wrap="square" lIns="0" tIns="0" rIns="0" bIns="0" anchor="t">
             <a:spAutoFit/>
           </a:bodyPr>
           <a:lstStyle/>
@@ -10226,7 +10373,7 @@
           <a:noFill/>
         </p:spPr>
         <p:txBody>
-          <a:bodyPr wrap="square" anchor="t" lIns="0" rIns="0" tIns="0" bIns="0">
+          <a:bodyPr wrap="square" lIns="0" tIns="0" rIns="0" bIns="0" anchor="t">
             <a:spAutoFit/>
           </a:bodyPr>
           <a:lstStyle/>
@@ -10269,7 +10416,7 @@
           <a:noFill/>
         </p:spPr>
         <p:txBody>
-          <a:bodyPr wrap="square" anchor="t" lIns="0" rIns="0" tIns="0" bIns="0">
+          <a:bodyPr wrap="square" lIns="0" tIns="0" rIns="0" bIns="0" anchor="t">
             <a:spAutoFit/>
           </a:bodyPr>
           <a:lstStyle/>
@@ -10311,7 +10458,7 @@
           <a:noFill/>
         </p:spPr>
         <p:txBody>
-          <a:bodyPr wrap="square" anchor="t" lIns="0" rIns="0" tIns="0" bIns="0">
+          <a:bodyPr wrap="square" lIns="0" tIns="0" rIns="0" bIns="0" anchor="t">
             <a:spAutoFit/>
           </a:bodyPr>
           <a:lstStyle/>
@@ -10354,7 +10501,7 @@
           <a:noFill/>
         </p:spPr>
         <p:txBody>
-          <a:bodyPr wrap="square" anchor="t" lIns="0" rIns="0" tIns="0" bIns="0">
+          <a:bodyPr wrap="square" lIns="0" tIns="0" rIns="0" bIns="0" anchor="t">
             <a:spAutoFit/>
           </a:bodyPr>
           <a:lstStyle/>
@@ -10396,7 +10543,7 @@
           <a:noFill/>
         </p:spPr>
         <p:txBody>
-          <a:bodyPr wrap="square" anchor="t" lIns="0" rIns="0" tIns="0" bIns="0">
+          <a:bodyPr wrap="square" lIns="0" tIns="0" rIns="0" bIns="0" anchor="t">
             <a:spAutoFit/>
           </a:bodyPr>
           <a:lstStyle/>
@@ -10439,7 +10586,7 @@
           <a:noFill/>
         </p:spPr>
         <p:txBody>
-          <a:bodyPr wrap="square" anchor="t" lIns="0" rIns="0" tIns="0" bIns="0">
+          <a:bodyPr wrap="square" lIns="0" tIns="0" rIns="0" bIns="0" anchor="t">
             <a:spAutoFit/>
           </a:bodyPr>
           <a:lstStyle/>
@@ -10481,7 +10628,7 @@
           <a:noFill/>
         </p:spPr>
         <p:txBody>
-          <a:bodyPr wrap="square" anchor="t" lIns="0" rIns="0" tIns="0" bIns="0">
+          <a:bodyPr wrap="square" lIns="0" tIns="0" rIns="0" bIns="0" anchor="t">
             <a:spAutoFit/>
           </a:bodyPr>
           <a:lstStyle/>
@@ -10523,7 +10670,7 @@
           <a:noFill/>
         </p:spPr>
         <p:txBody>
-          <a:bodyPr wrap="square" anchor="t" lIns="0" rIns="0" tIns="0" bIns="0">
+          <a:bodyPr wrap="square" lIns="0" tIns="0" rIns="0" bIns="0" anchor="t">
             <a:spAutoFit/>
           </a:bodyPr>
           <a:lstStyle/>
@@ -10565,7 +10712,7 @@
           <a:noFill/>
         </p:spPr>
         <p:txBody>
-          <a:bodyPr wrap="square" anchor="t" lIns="0" rIns="0" tIns="0" bIns="0">
+          <a:bodyPr wrap="square" lIns="0" tIns="0" rIns="0" bIns="0" anchor="t">
             <a:spAutoFit/>
           </a:bodyPr>
           <a:lstStyle/>
@@ -10631,6 +10778,7 @@
           <a:lstStyle/>
           <a:p>
             <a:pPr algn="ctr"/>
+            <a:endParaRPr/>
           </a:p>
         </p:txBody>
       </p:sp>
@@ -10651,7 +10799,7 @@
           <a:noFill/>
         </p:spPr>
         <p:txBody>
-          <a:bodyPr wrap="square" anchor="t" lIns="0" rIns="0" tIns="0" bIns="0">
+          <a:bodyPr wrap="square" lIns="0" tIns="0" rIns="0" bIns="0" anchor="t">
             <a:spAutoFit/>
           </a:bodyPr>
           <a:lstStyle/>
@@ -10717,6 +10865,7 @@
           <a:lstStyle/>
           <a:p>
             <a:pPr algn="ctr"/>
+            <a:endParaRPr/>
           </a:p>
         </p:txBody>
       </p:sp>
@@ -10737,7 +10886,7 @@
           <a:noFill/>
         </p:spPr>
         <p:txBody>
-          <a:bodyPr wrap="square" anchor="t" lIns="0" rIns="0" tIns="0" bIns="0">
+          <a:bodyPr wrap="square" lIns="0" tIns="0" rIns="0" bIns="0" anchor="t">
             <a:spAutoFit/>
           </a:bodyPr>
           <a:lstStyle/>
@@ -10803,6 +10952,7 @@
           <a:lstStyle/>
           <a:p>
             <a:pPr algn="ctr"/>
+            <a:endParaRPr/>
           </a:p>
         </p:txBody>
       </p:sp>
@@ -10823,7 +10973,7 @@
           <a:noFill/>
         </p:spPr>
         <p:txBody>
-          <a:bodyPr wrap="square" anchor="t" lIns="0" rIns="0" tIns="0" bIns="0">
+          <a:bodyPr wrap="square" lIns="0" tIns="0" rIns="0" bIns="0" anchor="t">
             <a:spAutoFit/>
           </a:bodyPr>
           <a:lstStyle/>
@@ -10889,6 +11039,7 @@
           <a:lstStyle/>
           <a:p>
             <a:pPr algn="ctr"/>
+            <a:endParaRPr/>
           </a:p>
         </p:txBody>
       </p:sp>
@@ -10909,7 +11060,7 @@
           <a:noFill/>
         </p:spPr>
         <p:txBody>
-          <a:bodyPr wrap="square" anchor="t" lIns="0" rIns="0" tIns="0" bIns="0">
+          <a:bodyPr wrap="square" lIns="0" tIns="0" rIns="0" bIns="0" anchor="t">
             <a:spAutoFit/>
           </a:bodyPr>
           <a:lstStyle/>
@@ -10975,6 +11126,7 @@
           <a:lstStyle/>
           <a:p>
             <a:pPr algn="ctr"/>
+            <a:endParaRPr/>
           </a:p>
         </p:txBody>
       </p:sp>
@@ -10995,7 +11147,7 @@
           <a:noFill/>
         </p:spPr>
         <p:txBody>
-          <a:bodyPr wrap="square" anchor="t" lIns="0" rIns="0" tIns="0" bIns="0">
+          <a:bodyPr wrap="square" lIns="0" tIns="0" rIns="0" bIns="0" anchor="t">
             <a:spAutoFit/>
           </a:bodyPr>
           <a:lstStyle/>
@@ -11037,7 +11189,7 @@
           <a:noFill/>
         </p:spPr>
         <p:txBody>
-          <a:bodyPr wrap="square" anchor="t" lIns="0" rIns="0" tIns="0" bIns="0">
+          <a:bodyPr wrap="square" lIns="0" tIns="0" rIns="0" bIns="0" anchor="t">
             <a:spAutoFit/>
           </a:bodyPr>
           <a:lstStyle/>
@@ -11067,11 +11219,23 @@
   <p:clrMapOvr>
     <a:masterClrMapping/>
   </p:clrMapOvr>
+  <mc:AlternateContent xmlns:mc="http://schemas.openxmlformats.org/markup-compatibility/2006">
+    <mc:Choice xmlns:p159="http://schemas.microsoft.com/office/powerpoint/2015/09/main" Requires="p159">
+      <p:transition xmlns:p14="http://schemas.microsoft.com/office/powerpoint/2010/main" spd="slow" p14:dur="2000">
+        <p159:morph option="byObject"/>
+      </p:transition>
+    </mc:Choice>
+    <mc:Fallback>
+      <p:transition spd="slow">
+        <p:fade/>
+      </p:transition>
+    </mc:Fallback>
+  </mc:AlternateContent>
 </p:sld>
 </file>
 
 <file path=ppt/slides/slide15.xml><?xml version="1.0" encoding="utf-8"?>
-<p:sld xmlns:a="http://schemas.openxmlformats.org/drawingml/2006/main" xmlns:p="http://schemas.openxmlformats.org/presentationml/2006/main" xmlns:r="http://schemas.openxmlformats.org/officeDocument/2006/relationships">
+<p:sld xmlns:a="http://schemas.openxmlformats.org/drawingml/2006/main" xmlns:r="http://schemas.openxmlformats.org/officeDocument/2006/relationships" xmlns:p="http://schemas.openxmlformats.org/presentationml/2006/main">
   <p:cSld>
     <p:spTree>
       <p:nvGrpSpPr>
@@ -11079,7 +11243,14 @@
         <p:cNvGrpSpPr/>
         <p:nvPr/>
       </p:nvGrpSpPr>
-      <p:grpSpPr/>
+      <p:grpSpPr>
+        <a:xfrm>
+          <a:off x="0" y="0"/>
+          <a:ext cx="0" cy="0"/>
+          <a:chOff x="0" y="0"/>
+          <a:chExt cx="0" cy="0"/>
+        </a:xfrm>
+      </p:grpSpPr>
       <p:sp>
         <p:nvSpPr>
           <p:cNvPr id="2" name="Rectangle 1"/>
@@ -11121,6 +11292,7 @@
           <a:lstStyle/>
           <a:p>
             <a:pPr algn="ctr"/>
+            <a:endParaRPr/>
           </a:p>
         </p:txBody>
       </p:sp>
@@ -11165,6 +11337,7 @@
           <a:lstStyle/>
           <a:p>
             <a:pPr algn="ctr"/>
+            <a:endParaRPr/>
           </a:p>
         </p:txBody>
       </p:sp>
@@ -11185,7 +11358,7 @@
           <a:noFill/>
         </p:spPr>
         <p:txBody>
-          <a:bodyPr wrap="square" anchor="t" lIns="0" rIns="0" tIns="0" bIns="0">
+          <a:bodyPr wrap="square" lIns="0" tIns="0" rIns="0" bIns="0" anchor="t">
             <a:spAutoFit/>
           </a:bodyPr>
           <a:lstStyle/>
@@ -11227,7 +11400,7 @@
           <a:noFill/>
         </p:spPr>
         <p:txBody>
-          <a:bodyPr wrap="square" anchor="t" lIns="0" rIns="0" tIns="0" bIns="0">
+          <a:bodyPr wrap="square" lIns="0" tIns="0" rIns="0" bIns="0" anchor="t">
             <a:spAutoFit/>
           </a:bodyPr>
           <a:lstStyle/>
@@ -11269,7 +11442,7 @@
           <a:noFill/>
         </p:spPr>
         <p:txBody>
-          <a:bodyPr wrap="square" anchor="t" lIns="0" rIns="0" tIns="0" bIns="0">
+          <a:bodyPr wrap="square" lIns="0" tIns="0" rIns="0" bIns="0" anchor="t">
             <a:spAutoFit/>
           </a:bodyPr>
           <a:lstStyle/>
@@ -11359,6 +11532,7 @@
           <a:lstStyle/>
           <a:p>
             <a:pPr algn="ctr"/>
+            <a:endParaRPr/>
           </a:p>
         </p:txBody>
       </p:sp>
@@ -11379,7 +11553,7 @@
           <a:noFill/>
         </p:spPr>
         <p:txBody>
-          <a:bodyPr wrap="square" anchor="t" lIns="0" rIns="0" tIns="0" bIns="0">
+          <a:bodyPr wrap="square" lIns="0" tIns="0" rIns="0" bIns="0" anchor="t">
             <a:spAutoFit/>
           </a:bodyPr>
           <a:lstStyle/>
@@ -11445,6 +11619,7 @@
           <a:lstStyle/>
           <a:p>
             <a:pPr algn="ctr"/>
+            <a:endParaRPr/>
           </a:p>
         </p:txBody>
       </p:sp>
@@ -11465,7 +11640,7 @@
           <a:noFill/>
         </p:spPr>
         <p:txBody>
-          <a:bodyPr wrap="square" anchor="t" lIns="0" rIns="0" tIns="0" bIns="0">
+          <a:bodyPr wrap="square" lIns="0" tIns="0" rIns="0" bIns="0" anchor="t">
             <a:spAutoFit/>
           </a:bodyPr>
           <a:lstStyle/>
@@ -11531,6 +11706,7 @@
           <a:lstStyle/>
           <a:p>
             <a:pPr algn="ctr"/>
+            <a:endParaRPr/>
           </a:p>
         </p:txBody>
       </p:sp>
@@ -11551,7 +11727,7 @@
           <a:noFill/>
         </p:spPr>
         <p:txBody>
-          <a:bodyPr wrap="square" anchor="t" lIns="0" rIns="0" tIns="0" bIns="0">
+          <a:bodyPr wrap="square" lIns="0" tIns="0" rIns="0" bIns="0" anchor="t">
             <a:spAutoFit/>
           </a:bodyPr>
           <a:lstStyle/>
@@ -11617,6 +11793,7 @@
           <a:lstStyle/>
           <a:p>
             <a:pPr algn="ctr"/>
+            <a:endParaRPr/>
           </a:p>
         </p:txBody>
       </p:sp>
@@ -11637,7 +11814,7 @@
           <a:noFill/>
         </p:spPr>
         <p:txBody>
-          <a:bodyPr wrap="square" anchor="t" lIns="0" rIns="0" tIns="0" bIns="0">
+          <a:bodyPr wrap="square" lIns="0" tIns="0" rIns="0" bIns="0" anchor="t">
             <a:spAutoFit/>
           </a:bodyPr>
           <a:lstStyle/>
@@ -11703,6 +11880,7 @@
           <a:lstStyle/>
           <a:p>
             <a:pPr algn="ctr"/>
+            <a:endParaRPr/>
           </a:p>
         </p:txBody>
       </p:sp>
@@ -11723,7 +11901,7 @@
           <a:noFill/>
         </p:spPr>
         <p:txBody>
-          <a:bodyPr wrap="square" anchor="t" lIns="0" rIns="0" tIns="0" bIns="0">
+          <a:bodyPr wrap="square" lIns="0" tIns="0" rIns="0" bIns="0" anchor="t">
             <a:spAutoFit/>
           </a:bodyPr>
           <a:lstStyle/>
@@ -11789,6 +11967,7 @@
           <a:lstStyle/>
           <a:p>
             <a:pPr algn="ctr"/>
+            <a:endParaRPr/>
           </a:p>
         </p:txBody>
       </p:sp>
@@ -11833,6 +12012,7 @@
           <a:lstStyle/>
           <a:p>
             <a:pPr algn="ctr"/>
+            <a:endParaRPr/>
           </a:p>
         </p:txBody>
       </p:sp>
@@ -11853,7 +12033,7 @@
           <a:noFill/>
         </p:spPr>
         <p:txBody>
-          <a:bodyPr wrap="square" anchor="t" lIns="0" rIns="0" tIns="0" bIns="0">
+          <a:bodyPr wrap="square" lIns="0" tIns="0" rIns="0" bIns="0" anchor="t">
             <a:spAutoFit/>
           </a:bodyPr>
           <a:lstStyle/>
@@ -11895,7 +12075,7 @@
           <a:noFill/>
         </p:spPr>
         <p:txBody>
-          <a:bodyPr wrap="square" anchor="t" lIns="0" rIns="0" tIns="0" bIns="0">
+          <a:bodyPr wrap="square" lIns="0" tIns="0" rIns="0" bIns="0" anchor="t">
             <a:spAutoFit/>
           </a:bodyPr>
           <a:lstStyle/>
@@ -11937,7 +12117,7 @@
           <a:noFill/>
         </p:spPr>
         <p:txBody>
-          <a:bodyPr wrap="square" anchor="t" lIns="0" rIns="0" tIns="0" bIns="0">
+          <a:bodyPr wrap="square" lIns="0" tIns="0" rIns="0" bIns="0" anchor="t">
             <a:spAutoFit/>
           </a:bodyPr>
           <a:lstStyle/>
@@ -11979,7 +12159,7 @@
           <a:noFill/>
         </p:spPr>
         <p:txBody>
-          <a:bodyPr wrap="square" anchor="t" lIns="0" rIns="0" tIns="0" bIns="0">
+          <a:bodyPr wrap="square" lIns="0" tIns="0" rIns="0" bIns="0" anchor="t">
             <a:spAutoFit/>
           </a:bodyPr>
           <a:lstStyle/>
@@ -12045,6 +12225,7 @@
           <a:lstStyle/>
           <a:p>
             <a:pPr algn="ctr"/>
+            <a:endParaRPr/>
           </a:p>
         </p:txBody>
       </p:sp>
@@ -12065,7 +12246,7 @@
           <a:noFill/>
         </p:spPr>
         <p:txBody>
-          <a:bodyPr wrap="square" anchor="t" lIns="0" rIns="0" tIns="0" bIns="0">
+          <a:bodyPr wrap="square" lIns="0" tIns="0" rIns="0" bIns="0" anchor="t">
             <a:spAutoFit/>
           </a:bodyPr>
           <a:lstStyle/>
@@ -12107,7 +12288,7 @@
           <a:noFill/>
         </p:spPr>
         <p:txBody>
-          <a:bodyPr wrap="square" anchor="t" lIns="0" rIns="0" tIns="0" bIns="0">
+          <a:bodyPr wrap="square" lIns="0" tIns="0" rIns="0" bIns="0" anchor="t">
             <a:spAutoFit/>
           </a:bodyPr>
           <a:lstStyle/>
@@ -12137,11 +12318,23 @@
   <p:clrMapOvr>
     <a:masterClrMapping/>
   </p:clrMapOvr>
+  <mc:AlternateContent xmlns:mc="http://schemas.openxmlformats.org/markup-compatibility/2006">
+    <mc:Choice xmlns:p159="http://schemas.microsoft.com/office/powerpoint/2015/09/main" Requires="p159">
+      <p:transition xmlns:p14="http://schemas.microsoft.com/office/powerpoint/2010/main" spd="slow" p14:dur="2000">
+        <p159:morph option="byObject"/>
+      </p:transition>
+    </mc:Choice>
+    <mc:Fallback>
+      <p:transition spd="slow">
+        <p:fade/>
+      </p:transition>
+    </mc:Fallback>
+  </mc:AlternateContent>
 </p:sld>
 </file>
 
 <file path=ppt/slides/slide16.xml><?xml version="1.0" encoding="utf-8"?>
-<p:sld xmlns:a="http://schemas.openxmlformats.org/drawingml/2006/main" xmlns:p="http://schemas.openxmlformats.org/presentationml/2006/main" xmlns:r="http://schemas.openxmlformats.org/officeDocument/2006/relationships">
+<p:sld xmlns:a="http://schemas.openxmlformats.org/drawingml/2006/main" xmlns:r="http://schemas.openxmlformats.org/officeDocument/2006/relationships" xmlns:p="http://schemas.openxmlformats.org/presentationml/2006/main">
   <p:cSld>
     <p:spTree>
       <p:nvGrpSpPr>
@@ -12149,7 +12342,14 @@
         <p:cNvGrpSpPr/>
         <p:nvPr/>
       </p:nvGrpSpPr>
-      <p:grpSpPr/>
+      <p:grpSpPr>
+        <a:xfrm>
+          <a:off x="0" y="0"/>
+          <a:ext cx="0" cy="0"/>
+          <a:chOff x="0" y="0"/>
+          <a:chExt cx="0" cy="0"/>
+        </a:xfrm>
+      </p:grpSpPr>
       <p:sp>
         <p:nvSpPr>
           <p:cNvPr id="2" name="Rectangle 1"/>
@@ -12191,6 +12391,7 @@
           <a:lstStyle/>
           <a:p>
             <a:pPr algn="ctr"/>
+            <a:endParaRPr/>
           </a:p>
         </p:txBody>
       </p:sp>
@@ -12235,6 +12436,7 @@
           <a:lstStyle/>
           <a:p>
             <a:pPr algn="ctr"/>
+            <a:endParaRPr/>
           </a:p>
         </p:txBody>
       </p:sp>
@@ -12255,7 +12457,7 @@
           <a:noFill/>
         </p:spPr>
         <p:txBody>
-          <a:bodyPr wrap="square" anchor="t" lIns="0" rIns="0" tIns="0" bIns="0">
+          <a:bodyPr wrap="square" lIns="0" tIns="0" rIns="0" bIns="0" anchor="t">
             <a:spAutoFit/>
           </a:bodyPr>
           <a:lstStyle/>
@@ -12297,7 +12499,7 @@
           <a:noFill/>
         </p:spPr>
         <p:txBody>
-          <a:bodyPr wrap="square" anchor="t" lIns="0" rIns="0" tIns="0" bIns="0">
+          <a:bodyPr wrap="square" lIns="0" tIns="0" rIns="0" bIns="0" anchor="t">
             <a:spAutoFit/>
           </a:bodyPr>
           <a:lstStyle/>
@@ -12363,6 +12565,7 @@
           <a:lstStyle/>
           <a:p>
             <a:pPr algn="ctr"/>
+            <a:endParaRPr/>
           </a:p>
         </p:txBody>
       </p:sp>
@@ -12383,7 +12586,7 @@
           <a:noFill/>
         </p:spPr>
         <p:txBody>
-          <a:bodyPr wrap="square" anchor="t" lIns="0" rIns="0" tIns="0" bIns="0">
+          <a:bodyPr wrap="square" lIns="0" tIns="0" rIns="0" bIns="0" anchor="t">
             <a:spAutoFit/>
           </a:bodyPr>
           <a:lstStyle/>
@@ -12437,11 +12640,23 @@
   <p:clrMapOvr>
     <a:masterClrMapping/>
   </p:clrMapOvr>
+  <mc:AlternateContent xmlns:mc="http://schemas.openxmlformats.org/markup-compatibility/2006">
+    <mc:Choice xmlns:p159="http://schemas.microsoft.com/office/powerpoint/2015/09/main" Requires="p159">
+      <p:transition xmlns:p14="http://schemas.microsoft.com/office/powerpoint/2010/main" spd="slow" p14:dur="2000">
+        <p159:morph option="byObject"/>
+      </p:transition>
+    </mc:Choice>
+    <mc:Fallback>
+      <p:transition spd="slow">
+        <p:fade/>
+      </p:transition>
+    </mc:Fallback>
+  </mc:AlternateContent>
 </p:sld>
 </file>
 
 <file path=ppt/slides/slide17.xml><?xml version="1.0" encoding="utf-8"?>
-<p:sld xmlns:a="http://schemas.openxmlformats.org/drawingml/2006/main" xmlns:p="http://schemas.openxmlformats.org/presentationml/2006/main" xmlns:r="http://schemas.openxmlformats.org/officeDocument/2006/relationships">
+<p:sld xmlns:a="http://schemas.openxmlformats.org/drawingml/2006/main" xmlns:r="http://schemas.openxmlformats.org/officeDocument/2006/relationships" xmlns:p="http://schemas.openxmlformats.org/presentationml/2006/main">
   <p:cSld>
     <p:spTree>
       <p:nvGrpSpPr>
@@ -12449,7 +12664,14 @@
         <p:cNvGrpSpPr/>
         <p:nvPr/>
       </p:nvGrpSpPr>
-      <p:grpSpPr/>
+      <p:grpSpPr>
+        <a:xfrm>
+          <a:off x="0" y="0"/>
+          <a:ext cx="0" cy="0"/>
+          <a:chOff x="0" y="0"/>
+          <a:chExt cx="0" cy="0"/>
+        </a:xfrm>
+      </p:grpSpPr>
       <p:sp>
         <p:nvSpPr>
           <p:cNvPr id="2" name="Rectangle 1"/>
@@ -12491,6 +12713,7 @@
           <a:lstStyle/>
           <a:p>
             <a:pPr algn="ctr"/>
+            <a:endParaRPr/>
           </a:p>
         </p:txBody>
       </p:sp>
@@ -12535,6 +12758,7 @@
           <a:lstStyle/>
           <a:p>
             <a:pPr algn="ctr"/>
+            <a:endParaRPr/>
           </a:p>
         </p:txBody>
       </p:sp>
@@ -12579,6 +12803,7 @@
           <a:lstStyle/>
           <a:p>
             <a:pPr algn="ctr"/>
+            <a:endParaRPr/>
           </a:p>
         </p:txBody>
       </p:sp>
@@ -12623,7 +12848,7 @@
           <a:noFill/>
         </p:spPr>
         <p:txBody>
-          <a:bodyPr wrap="square" anchor="t" lIns="0" rIns="0" tIns="0" bIns="0">
+          <a:bodyPr wrap="square" lIns="0" tIns="0" rIns="0" bIns="0" anchor="t">
             <a:spAutoFit/>
           </a:bodyPr>
           <a:lstStyle/>
@@ -12665,7 +12890,7 @@
           <a:noFill/>
         </p:spPr>
         <p:txBody>
-          <a:bodyPr wrap="square" anchor="t" lIns="0" rIns="0" tIns="0" bIns="0">
+          <a:bodyPr wrap="square" lIns="0" tIns="0" rIns="0" bIns="0" anchor="t">
             <a:spAutoFit/>
           </a:bodyPr>
           <a:lstStyle/>
@@ -12731,6 +12956,7 @@
           <a:lstStyle/>
           <a:p>
             <a:pPr algn="ctr"/>
+            <a:endParaRPr/>
           </a:p>
         </p:txBody>
       </p:sp>
@@ -12751,7 +12977,7 @@
           <a:noFill/>
         </p:spPr>
         <p:txBody>
-          <a:bodyPr wrap="square" anchor="t" lIns="0" rIns="0" tIns="0" bIns="0">
+          <a:bodyPr wrap="square" lIns="0" tIns="0" rIns="0" bIns="0" anchor="t">
             <a:spAutoFit/>
           </a:bodyPr>
           <a:lstStyle/>
@@ -12793,7 +13019,7 @@
           <a:noFill/>
         </p:spPr>
         <p:txBody>
-          <a:bodyPr wrap="square" anchor="t" lIns="0" rIns="0" tIns="0" bIns="0">
+          <a:bodyPr wrap="square" lIns="0" tIns="0" rIns="0" bIns="0" anchor="t">
             <a:spAutoFit/>
           </a:bodyPr>
           <a:lstStyle/>
@@ -12823,11 +13049,23 @@
   <p:clrMapOvr>
     <a:masterClrMapping/>
   </p:clrMapOvr>
+  <mc:AlternateContent xmlns:mc="http://schemas.openxmlformats.org/markup-compatibility/2006">
+    <mc:Choice xmlns:p159="http://schemas.microsoft.com/office/powerpoint/2015/09/main" Requires="p159">
+      <p:transition xmlns:p14="http://schemas.microsoft.com/office/powerpoint/2010/main" spd="slow" p14:dur="2000">
+        <p159:morph option="byObject"/>
+      </p:transition>
+    </mc:Choice>
+    <mc:Fallback>
+      <p:transition spd="slow">
+        <p:fade/>
+      </p:transition>
+    </mc:Fallback>
+  </mc:AlternateContent>
 </p:sld>
 </file>
 
 <file path=ppt/slides/slide2.xml><?xml version="1.0" encoding="utf-8"?>
-<p:sld xmlns:a="http://schemas.openxmlformats.org/drawingml/2006/main" xmlns:p="http://schemas.openxmlformats.org/presentationml/2006/main" xmlns:r="http://schemas.openxmlformats.org/officeDocument/2006/relationships">
+<p:sld xmlns:a="http://schemas.openxmlformats.org/drawingml/2006/main" xmlns:r="http://schemas.openxmlformats.org/officeDocument/2006/relationships" xmlns:p="http://schemas.openxmlformats.org/presentationml/2006/main">
   <p:cSld>
     <p:spTree>
       <p:nvGrpSpPr>
@@ -12835,7 +13073,14 @@
         <p:cNvGrpSpPr/>
         <p:nvPr/>
       </p:nvGrpSpPr>
-      <p:grpSpPr/>
+      <p:grpSpPr>
+        <a:xfrm>
+          <a:off x="0" y="0"/>
+          <a:ext cx="0" cy="0"/>
+          <a:chOff x="0" y="0"/>
+          <a:chExt cx="0" cy="0"/>
+        </a:xfrm>
+      </p:grpSpPr>
       <p:sp>
         <p:nvSpPr>
           <p:cNvPr id="2" name="Rectangle 1"/>
@@ -12877,6 +13122,7 @@
           <a:lstStyle/>
           <a:p>
             <a:pPr algn="ctr"/>
+            <a:endParaRPr/>
           </a:p>
         </p:txBody>
       </p:sp>
@@ -12921,6 +13167,7 @@
           <a:lstStyle/>
           <a:p>
             <a:pPr algn="ctr"/>
+            <a:endParaRPr/>
           </a:p>
         </p:txBody>
       </p:sp>
@@ -12941,7 +13188,7 @@
           <a:noFill/>
         </p:spPr>
         <p:txBody>
-          <a:bodyPr wrap="square" anchor="t" lIns="0" rIns="0" tIns="0" bIns="0">
+          <a:bodyPr wrap="square" lIns="0" tIns="0" rIns="0" bIns="0" anchor="t">
             <a:spAutoFit/>
           </a:bodyPr>
           <a:lstStyle/>
@@ -12983,7 +13230,7 @@
           <a:noFill/>
         </p:spPr>
         <p:txBody>
-          <a:bodyPr wrap="square" anchor="t" lIns="0" rIns="0" tIns="0" bIns="0">
+          <a:bodyPr wrap="square" lIns="0" tIns="0" rIns="0" bIns="0" anchor="t">
             <a:spAutoFit/>
           </a:bodyPr>
           <a:lstStyle/>
@@ -13025,7 +13272,7 @@
           <a:noFill/>
         </p:spPr>
         <p:txBody>
-          <a:bodyPr wrap="square" anchor="t" lIns="0" rIns="0" tIns="0" bIns="0">
+          <a:bodyPr wrap="square" lIns="0" tIns="0" rIns="0" bIns="0" anchor="t">
             <a:spAutoFit/>
           </a:bodyPr>
           <a:lstStyle/>
@@ -13115,6 +13362,7 @@
           <a:lstStyle/>
           <a:p>
             <a:pPr algn="ctr"/>
+            <a:endParaRPr/>
           </a:p>
         </p:txBody>
       </p:sp>
@@ -13135,7 +13383,7 @@
           <a:noFill/>
         </p:spPr>
         <p:txBody>
-          <a:bodyPr wrap="square" anchor="t" lIns="0" rIns="0" tIns="0" bIns="0">
+          <a:bodyPr wrap="square" lIns="0" tIns="0" rIns="0" bIns="0" anchor="t">
             <a:spAutoFit/>
           </a:bodyPr>
           <a:lstStyle/>
@@ -13201,6 +13449,7 @@
           <a:lstStyle/>
           <a:p>
             <a:pPr algn="ctr"/>
+            <a:endParaRPr/>
           </a:p>
         </p:txBody>
       </p:sp>
@@ -13221,7 +13470,7 @@
           <a:noFill/>
         </p:spPr>
         <p:txBody>
-          <a:bodyPr wrap="square" anchor="t" lIns="0" rIns="0" tIns="0" bIns="0">
+          <a:bodyPr wrap="square" lIns="0" tIns="0" rIns="0" bIns="0" anchor="t">
             <a:spAutoFit/>
           </a:bodyPr>
           <a:lstStyle/>
@@ -13287,6 +13536,7 @@
           <a:lstStyle/>
           <a:p>
             <a:pPr algn="ctr"/>
+            <a:endParaRPr/>
           </a:p>
         </p:txBody>
       </p:sp>
@@ -13307,7 +13557,7 @@
           <a:noFill/>
         </p:spPr>
         <p:txBody>
-          <a:bodyPr wrap="square" anchor="t" lIns="0" rIns="0" tIns="0" bIns="0">
+          <a:bodyPr wrap="square" lIns="0" tIns="0" rIns="0" bIns="0" anchor="t">
             <a:spAutoFit/>
           </a:bodyPr>
           <a:lstStyle/>
@@ -13373,6 +13623,7 @@
           <a:lstStyle/>
           <a:p>
             <a:pPr algn="ctr"/>
+            <a:endParaRPr/>
           </a:p>
         </p:txBody>
       </p:sp>
@@ -13393,7 +13644,7 @@
           <a:noFill/>
         </p:spPr>
         <p:txBody>
-          <a:bodyPr wrap="square" anchor="t" lIns="0" rIns="0" tIns="0" bIns="0">
+          <a:bodyPr wrap="square" lIns="0" tIns="0" rIns="0" bIns="0" anchor="t">
             <a:spAutoFit/>
           </a:bodyPr>
           <a:lstStyle/>
@@ -13435,7 +13686,7 @@
           <a:noFill/>
         </p:spPr>
         <p:txBody>
-          <a:bodyPr wrap="square" anchor="t" lIns="0" rIns="0" tIns="0" bIns="0">
+          <a:bodyPr wrap="square" lIns="0" tIns="0" rIns="0" bIns="0" anchor="t">
             <a:spAutoFit/>
           </a:bodyPr>
           <a:lstStyle/>
@@ -13478,7 +13729,7 @@
           <a:noFill/>
         </p:spPr>
         <p:txBody>
-          <a:bodyPr wrap="square" anchor="t" lIns="0" rIns="0" tIns="0" bIns="0">
+          <a:bodyPr wrap="square" lIns="0" tIns="0" rIns="0" bIns="0" anchor="t">
             <a:spAutoFit/>
           </a:bodyPr>
           <a:lstStyle/>
@@ -13520,7 +13771,7 @@
           <a:noFill/>
         </p:spPr>
         <p:txBody>
-          <a:bodyPr wrap="square" anchor="t" lIns="0" rIns="0" tIns="0" bIns="0">
+          <a:bodyPr wrap="square" lIns="0" tIns="0" rIns="0" bIns="0" anchor="t">
             <a:spAutoFit/>
           </a:bodyPr>
           <a:lstStyle/>
@@ -13563,7 +13814,7 @@
           <a:noFill/>
         </p:spPr>
         <p:txBody>
-          <a:bodyPr wrap="square" anchor="t" lIns="0" rIns="0" tIns="0" bIns="0">
+          <a:bodyPr wrap="square" lIns="0" tIns="0" rIns="0" bIns="0" anchor="t">
             <a:spAutoFit/>
           </a:bodyPr>
           <a:lstStyle/>
@@ -13605,7 +13856,7 @@
           <a:noFill/>
         </p:spPr>
         <p:txBody>
-          <a:bodyPr wrap="square" anchor="t" lIns="0" rIns="0" tIns="0" bIns="0">
+          <a:bodyPr wrap="square" lIns="0" tIns="0" rIns="0" bIns="0" anchor="t">
             <a:spAutoFit/>
           </a:bodyPr>
           <a:lstStyle/>
@@ -13648,7 +13899,7 @@
           <a:noFill/>
         </p:spPr>
         <p:txBody>
-          <a:bodyPr wrap="square" anchor="t" lIns="0" rIns="0" tIns="0" bIns="0">
+          <a:bodyPr wrap="square" lIns="0" tIns="0" rIns="0" bIns="0" anchor="t">
             <a:spAutoFit/>
           </a:bodyPr>
           <a:lstStyle/>
@@ -13690,7 +13941,7 @@
           <a:noFill/>
         </p:spPr>
         <p:txBody>
-          <a:bodyPr wrap="square" anchor="t" lIns="0" rIns="0" tIns="0" bIns="0">
+          <a:bodyPr wrap="square" lIns="0" tIns="0" rIns="0" bIns="0" anchor="t">
             <a:spAutoFit/>
           </a:bodyPr>
           <a:lstStyle/>
@@ -13733,7 +13984,7 @@
           <a:noFill/>
         </p:spPr>
         <p:txBody>
-          <a:bodyPr wrap="square" anchor="t" lIns="0" rIns="0" tIns="0" bIns="0">
+          <a:bodyPr wrap="square" lIns="0" tIns="0" rIns="0" bIns="0" anchor="t">
             <a:spAutoFit/>
           </a:bodyPr>
           <a:lstStyle/>
@@ -13799,6 +14050,7 @@
           <a:lstStyle/>
           <a:p>
             <a:pPr algn="ctr"/>
+            <a:endParaRPr/>
           </a:p>
         </p:txBody>
       </p:sp>
@@ -13819,7 +14071,7 @@
           <a:noFill/>
         </p:spPr>
         <p:txBody>
-          <a:bodyPr wrap="square" anchor="t" lIns="0" rIns="0" tIns="0" bIns="0">
+          <a:bodyPr wrap="square" lIns="0" tIns="0" rIns="0" bIns="0" anchor="t">
             <a:spAutoFit/>
           </a:bodyPr>
           <a:lstStyle/>
@@ -13861,7 +14113,7 @@
           <a:noFill/>
         </p:spPr>
         <p:txBody>
-          <a:bodyPr wrap="square" anchor="t" lIns="0" rIns="0" tIns="0" bIns="0">
+          <a:bodyPr wrap="square" lIns="0" tIns="0" rIns="0" bIns="0" anchor="t">
             <a:spAutoFit/>
           </a:bodyPr>
           <a:lstStyle/>
@@ -13891,11 +14143,23 @@
   <p:clrMapOvr>
     <a:masterClrMapping/>
   </p:clrMapOvr>
+  <mc:AlternateContent xmlns:mc="http://schemas.openxmlformats.org/markup-compatibility/2006">
+    <mc:Choice xmlns:p159="http://schemas.microsoft.com/office/powerpoint/2015/09/main" Requires="p159">
+      <p:transition xmlns:p14="http://schemas.microsoft.com/office/powerpoint/2010/main" spd="slow" p14:dur="2000">
+        <p159:morph option="byObject"/>
+      </p:transition>
+    </mc:Choice>
+    <mc:Fallback>
+      <p:transition spd="slow">
+        <p:fade/>
+      </p:transition>
+    </mc:Fallback>
+  </mc:AlternateContent>
 </p:sld>
 </file>
 
 <file path=ppt/slides/slide3.xml><?xml version="1.0" encoding="utf-8"?>
-<p:sld xmlns:a="http://schemas.openxmlformats.org/drawingml/2006/main" xmlns:p="http://schemas.openxmlformats.org/presentationml/2006/main" xmlns:r="http://schemas.openxmlformats.org/officeDocument/2006/relationships">
+<p:sld xmlns:a="http://schemas.openxmlformats.org/drawingml/2006/main" xmlns:r="http://schemas.openxmlformats.org/officeDocument/2006/relationships" xmlns:p="http://schemas.openxmlformats.org/presentationml/2006/main">
   <p:cSld>
     <p:spTree>
       <p:nvGrpSpPr>
@@ -13903,7 +14167,14 @@
         <p:cNvGrpSpPr/>
         <p:nvPr/>
       </p:nvGrpSpPr>
-      <p:grpSpPr/>
+      <p:grpSpPr>
+        <a:xfrm>
+          <a:off x="0" y="0"/>
+          <a:ext cx="0" cy="0"/>
+          <a:chOff x="0" y="0"/>
+          <a:chExt cx="0" cy="0"/>
+        </a:xfrm>
+      </p:grpSpPr>
       <p:sp>
         <p:nvSpPr>
           <p:cNvPr id="2" name="Rectangle 1"/>
@@ -13945,6 +14216,7 @@
           <a:lstStyle/>
           <a:p>
             <a:pPr algn="ctr"/>
+            <a:endParaRPr/>
           </a:p>
         </p:txBody>
       </p:sp>
@@ -13989,6 +14261,7 @@
           <a:lstStyle/>
           <a:p>
             <a:pPr algn="ctr"/>
+            <a:endParaRPr/>
           </a:p>
         </p:txBody>
       </p:sp>
@@ -14009,7 +14282,7 @@
           <a:noFill/>
         </p:spPr>
         <p:txBody>
-          <a:bodyPr wrap="square" anchor="t" lIns="0" rIns="0" tIns="0" bIns="0">
+          <a:bodyPr wrap="square" lIns="0" tIns="0" rIns="0" bIns="0" anchor="t">
             <a:spAutoFit/>
           </a:bodyPr>
           <a:lstStyle/>
@@ -14051,7 +14324,7 @@
           <a:noFill/>
         </p:spPr>
         <p:txBody>
-          <a:bodyPr wrap="square" anchor="t" lIns="0" rIns="0" tIns="0" bIns="0">
+          <a:bodyPr wrap="square" lIns="0" tIns="0" rIns="0" bIns="0" anchor="t">
             <a:spAutoFit/>
           </a:bodyPr>
           <a:lstStyle/>
@@ -14093,7 +14366,7 @@
           <a:noFill/>
         </p:spPr>
         <p:txBody>
-          <a:bodyPr wrap="square" anchor="t" lIns="0" rIns="0" tIns="0" bIns="0">
+          <a:bodyPr wrap="square" lIns="0" tIns="0" rIns="0" bIns="0" anchor="t">
             <a:spAutoFit/>
           </a:bodyPr>
           <a:lstStyle/>
@@ -14159,6 +14432,7 @@
           <a:lstStyle/>
           <a:p>
             <a:pPr algn="ctr"/>
+            <a:endParaRPr/>
           </a:p>
         </p:txBody>
       </p:sp>
@@ -14203,6 +14477,7 @@
           <a:lstStyle/>
           <a:p>
             <a:pPr algn="ctr"/>
+            <a:endParaRPr/>
           </a:p>
         </p:txBody>
       </p:sp>
@@ -14223,7 +14498,7 @@
           <a:noFill/>
         </p:spPr>
         <p:txBody>
-          <a:bodyPr wrap="square" anchor="t" lIns="0" rIns="0" tIns="0" bIns="0">
+          <a:bodyPr wrap="square" lIns="0" tIns="0" rIns="0" bIns="0" anchor="t">
             <a:spAutoFit/>
           </a:bodyPr>
           <a:lstStyle/>
@@ -14265,7 +14540,7 @@
           <a:noFill/>
         </p:spPr>
         <p:txBody>
-          <a:bodyPr wrap="square" anchor="t" lIns="0" rIns="0" tIns="0" bIns="0">
+          <a:bodyPr wrap="square" lIns="0" tIns="0" rIns="0" bIns="0" anchor="t">
             <a:spAutoFit/>
           </a:bodyPr>
           <a:lstStyle/>
@@ -14307,7 +14582,7 @@
           <a:noFill/>
         </p:spPr>
         <p:txBody>
-          <a:bodyPr wrap="square" anchor="t" lIns="0" rIns="0" tIns="0" bIns="0">
+          <a:bodyPr wrap="square" lIns="0" tIns="0" rIns="0" bIns="0" anchor="t">
             <a:spAutoFit/>
           </a:bodyPr>
           <a:lstStyle/>
@@ -14374,6 +14649,7 @@
           <a:lstStyle/>
           <a:p>
             <a:pPr algn="ctr"/>
+            <a:endParaRPr/>
           </a:p>
         </p:txBody>
       </p:sp>
@@ -14418,6 +14694,7 @@
           <a:lstStyle/>
           <a:p>
             <a:pPr algn="ctr"/>
+            <a:endParaRPr/>
           </a:p>
         </p:txBody>
       </p:sp>
@@ -14438,7 +14715,7 @@
           <a:noFill/>
         </p:spPr>
         <p:txBody>
-          <a:bodyPr wrap="square" anchor="t" lIns="0" rIns="0" tIns="0" bIns="0">
+          <a:bodyPr wrap="square" lIns="0" tIns="0" rIns="0" bIns="0" anchor="t">
             <a:spAutoFit/>
           </a:bodyPr>
           <a:lstStyle/>
@@ -14480,7 +14757,7 @@
           <a:noFill/>
         </p:spPr>
         <p:txBody>
-          <a:bodyPr wrap="square" anchor="t" lIns="0" rIns="0" tIns="0" bIns="0">
+          <a:bodyPr wrap="square" lIns="0" tIns="0" rIns="0" bIns="0" anchor="t">
             <a:spAutoFit/>
           </a:bodyPr>
           <a:lstStyle/>
@@ -14522,7 +14799,7 @@
           <a:noFill/>
         </p:spPr>
         <p:txBody>
-          <a:bodyPr wrap="square" anchor="t" lIns="0" rIns="0" tIns="0" bIns="0">
+          <a:bodyPr wrap="square" lIns="0" tIns="0" rIns="0" bIns="0" anchor="t">
             <a:spAutoFit/>
           </a:bodyPr>
           <a:lstStyle/>
@@ -14589,6 +14866,7 @@
           <a:lstStyle/>
           <a:p>
             <a:pPr algn="ctr"/>
+            <a:endParaRPr/>
           </a:p>
         </p:txBody>
       </p:sp>
@@ -14633,6 +14911,7 @@
           <a:lstStyle/>
           <a:p>
             <a:pPr algn="ctr"/>
+            <a:endParaRPr/>
           </a:p>
         </p:txBody>
       </p:sp>
@@ -14653,7 +14932,7 @@
           <a:noFill/>
         </p:spPr>
         <p:txBody>
-          <a:bodyPr wrap="square" anchor="t" lIns="0" rIns="0" tIns="0" bIns="0">
+          <a:bodyPr wrap="square" lIns="0" tIns="0" rIns="0" bIns="0" anchor="t">
             <a:spAutoFit/>
           </a:bodyPr>
           <a:lstStyle/>
@@ -14695,7 +14974,7 @@
           <a:noFill/>
         </p:spPr>
         <p:txBody>
-          <a:bodyPr wrap="square" anchor="t" lIns="0" rIns="0" tIns="0" bIns="0">
+          <a:bodyPr wrap="square" lIns="0" tIns="0" rIns="0" bIns="0" anchor="t">
             <a:spAutoFit/>
           </a:bodyPr>
           <a:lstStyle/>
@@ -14737,7 +15016,7 @@
           <a:noFill/>
         </p:spPr>
         <p:txBody>
-          <a:bodyPr wrap="square" anchor="t" lIns="0" rIns="0" tIns="0" bIns="0">
+          <a:bodyPr wrap="square" lIns="0" tIns="0" rIns="0" bIns="0" anchor="t">
             <a:spAutoFit/>
           </a:bodyPr>
           <a:lstStyle/>
@@ -14780,7 +15059,7 @@
           <a:noFill/>
         </p:spPr>
         <p:txBody>
-          <a:bodyPr wrap="square" anchor="t" lIns="0" rIns="0" tIns="0" bIns="0">
+          <a:bodyPr wrap="square" lIns="0" tIns="0" rIns="0" bIns="0" anchor="t">
             <a:spAutoFit/>
           </a:bodyPr>
           <a:lstStyle/>
@@ -14810,11 +15089,23 @@
   <p:clrMapOvr>
     <a:masterClrMapping/>
   </p:clrMapOvr>
+  <mc:AlternateContent xmlns:mc="http://schemas.openxmlformats.org/markup-compatibility/2006">
+    <mc:Choice xmlns:p159="http://schemas.microsoft.com/office/powerpoint/2015/09/main" Requires="p159">
+      <p:transition xmlns:p14="http://schemas.microsoft.com/office/powerpoint/2010/main" spd="slow" p14:dur="2000">
+        <p159:morph option="byObject"/>
+      </p:transition>
+    </mc:Choice>
+    <mc:Fallback>
+      <p:transition spd="slow">
+        <p:fade/>
+      </p:transition>
+    </mc:Fallback>
+  </mc:AlternateContent>
 </p:sld>
 </file>
 
 <file path=ppt/slides/slide4.xml><?xml version="1.0" encoding="utf-8"?>
-<p:sld xmlns:a="http://schemas.openxmlformats.org/drawingml/2006/main" xmlns:p="http://schemas.openxmlformats.org/presentationml/2006/main" xmlns:r="http://schemas.openxmlformats.org/officeDocument/2006/relationships">
+<p:sld xmlns:a="http://schemas.openxmlformats.org/drawingml/2006/main" xmlns:r="http://schemas.openxmlformats.org/officeDocument/2006/relationships" xmlns:p="http://schemas.openxmlformats.org/presentationml/2006/main">
   <p:cSld>
     <p:spTree>
       <p:nvGrpSpPr>
@@ -14822,7 +15113,14 @@
         <p:cNvGrpSpPr/>
         <p:nvPr/>
       </p:nvGrpSpPr>
-      <p:grpSpPr/>
+      <p:grpSpPr>
+        <a:xfrm>
+          <a:off x="0" y="0"/>
+          <a:ext cx="0" cy="0"/>
+          <a:chOff x="0" y="0"/>
+          <a:chExt cx="0" cy="0"/>
+        </a:xfrm>
+      </p:grpSpPr>
       <p:sp>
         <p:nvSpPr>
           <p:cNvPr id="2" name="Rectangle 1"/>
@@ -14864,6 +15162,7 @@
           <a:lstStyle/>
           <a:p>
             <a:pPr algn="ctr"/>
+            <a:endParaRPr/>
           </a:p>
         </p:txBody>
       </p:sp>
@@ -14908,6 +15207,7 @@
           <a:lstStyle/>
           <a:p>
             <a:pPr algn="ctr"/>
+            <a:endParaRPr/>
           </a:p>
         </p:txBody>
       </p:sp>
@@ -14928,7 +15228,7 @@
           <a:noFill/>
         </p:spPr>
         <p:txBody>
-          <a:bodyPr wrap="square" anchor="t" lIns="0" rIns="0" tIns="0" bIns="0">
+          <a:bodyPr wrap="square" lIns="0" tIns="0" rIns="0" bIns="0" anchor="t">
             <a:spAutoFit/>
           </a:bodyPr>
           <a:lstStyle/>
@@ -14970,7 +15270,7 @@
           <a:noFill/>
         </p:spPr>
         <p:txBody>
-          <a:bodyPr wrap="square" anchor="t" lIns="0" rIns="0" tIns="0" bIns="0">
+          <a:bodyPr wrap="square" lIns="0" tIns="0" rIns="0" bIns="0" anchor="t">
             <a:spAutoFit/>
           </a:bodyPr>
           <a:lstStyle/>
@@ -15012,7 +15312,7 @@
           <a:noFill/>
         </p:spPr>
         <p:txBody>
-          <a:bodyPr wrap="square" anchor="t" lIns="0" rIns="0" tIns="0" bIns="0">
+          <a:bodyPr wrap="square" lIns="0" tIns="0" rIns="0" bIns="0" anchor="t">
             <a:spAutoFit/>
           </a:bodyPr>
           <a:lstStyle/>
@@ -15104,6 +15404,7 @@
           <a:lstStyle/>
           <a:p>
             <a:pPr algn="ctr"/>
+            <a:endParaRPr/>
           </a:p>
         </p:txBody>
       </p:sp>
@@ -15124,7 +15425,7 @@
           <a:noFill/>
         </p:spPr>
         <p:txBody>
-          <a:bodyPr wrap="square" anchor="t" lIns="0" rIns="0" tIns="0" bIns="0">
+          <a:bodyPr wrap="square" lIns="0" tIns="0" rIns="0" bIns="0" anchor="t">
             <a:spAutoFit/>
           </a:bodyPr>
           <a:lstStyle/>
@@ -15193,6 +15494,7 @@
           <a:lstStyle/>
           <a:p>
             <a:pPr algn="ctr"/>
+            <a:endParaRPr/>
           </a:p>
         </p:txBody>
       </p:sp>
@@ -15213,7 +15515,7 @@
           <a:noFill/>
         </p:spPr>
         <p:txBody>
-          <a:bodyPr wrap="square" anchor="t" lIns="0" rIns="0" tIns="0" bIns="0">
+          <a:bodyPr wrap="square" lIns="0" tIns="0" rIns="0" bIns="0" anchor="t">
             <a:spAutoFit/>
           </a:bodyPr>
           <a:lstStyle/>
@@ -15280,6 +15582,7 @@
           <a:lstStyle/>
           <a:p>
             <a:pPr algn="ctr"/>
+            <a:endParaRPr/>
           </a:p>
         </p:txBody>
       </p:sp>
@@ -15324,6 +15627,7 @@
           <a:lstStyle/>
           <a:p>
             <a:pPr algn="ctr"/>
+            <a:endParaRPr/>
           </a:p>
         </p:txBody>
       </p:sp>
@@ -15368,6 +15672,7 @@
           <a:lstStyle/>
           <a:p>
             <a:pPr algn="ctr"/>
+            <a:endParaRPr/>
           </a:p>
         </p:txBody>
       </p:sp>
@@ -15388,7 +15693,7 @@
           <a:noFill/>
         </p:spPr>
         <p:txBody>
-          <a:bodyPr wrap="square" anchor="t" lIns="0" rIns="0" tIns="0" bIns="0">
+          <a:bodyPr wrap="square" lIns="0" tIns="0" rIns="0" bIns="0" anchor="t">
             <a:spAutoFit/>
           </a:bodyPr>
           <a:lstStyle/>
@@ -15430,7 +15735,7 @@
           <a:noFill/>
         </p:spPr>
         <p:txBody>
-          <a:bodyPr wrap="square" anchor="t" lIns="0" rIns="0" tIns="0" bIns="0">
+          <a:bodyPr wrap="square" lIns="0" tIns="0" rIns="0" bIns="0" anchor="t">
             <a:spAutoFit/>
           </a:bodyPr>
           <a:lstStyle/>
@@ -15498,6 +15803,7 @@
           <a:lstStyle/>
           <a:p>
             <a:pPr algn="ctr"/>
+            <a:endParaRPr/>
           </a:p>
         </p:txBody>
       </p:sp>
@@ -15542,6 +15848,7 @@
           <a:lstStyle/>
           <a:p>
             <a:pPr algn="ctr"/>
+            <a:endParaRPr/>
           </a:p>
         </p:txBody>
       </p:sp>
@@ -15562,7 +15869,7 @@
           <a:noFill/>
         </p:spPr>
         <p:txBody>
-          <a:bodyPr wrap="square" anchor="t" lIns="0" rIns="0" tIns="0" bIns="0">
+          <a:bodyPr wrap="square" lIns="0" tIns="0" rIns="0" bIns="0" anchor="t">
             <a:spAutoFit/>
           </a:bodyPr>
           <a:lstStyle/>
@@ -15628,6 +15935,7 @@
           <a:lstStyle/>
           <a:p>
             <a:pPr algn="ctr"/>
+            <a:endParaRPr/>
           </a:p>
         </p:txBody>
       </p:sp>
@@ -15648,7 +15956,7 @@
           <a:noFill/>
         </p:spPr>
         <p:txBody>
-          <a:bodyPr wrap="square" anchor="t" lIns="0" rIns="0" tIns="0" bIns="0">
+          <a:bodyPr wrap="square" lIns="0" tIns="0" rIns="0" bIns="0" anchor="t">
             <a:spAutoFit/>
           </a:bodyPr>
           <a:lstStyle/>
@@ -15714,6 +16022,7 @@
           <a:lstStyle/>
           <a:p>
             <a:pPr algn="ctr"/>
+            <a:endParaRPr/>
           </a:p>
         </p:txBody>
       </p:sp>
@@ -15734,7 +16043,7 @@
           <a:noFill/>
         </p:spPr>
         <p:txBody>
-          <a:bodyPr wrap="square" anchor="t" lIns="0" rIns="0" tIns="0" bIns="0">
+          <a:bodyPr wrap="square" lIns="0" tIns="0" rIns="0" bIns="0" anchor="t">
             <a:spAutoFit/>
           </a:bodyPr>
           <a:lstStyle/>
@@ -15800,6 +16109,7 @@
           <a:lstStyle/>
           <a:p>
             <a:pPr algn="ctr"/>
+            <a:endParaRPr/>
           </a:p>
         </p:txBody>
       </p:sp>
@@ -15820,7 +16130,7 @@
           <a:noFill/>
         </p:spPr>
         <p:txBody>
-          <a:bodyPr wrap="square" anchor="t" lIns="0" rIns="0" tIns="0" bIns="0">
+          <a:bodyPr wrap="square" lIns="0" tIns="0" rIns="0" bIns="0" anchor="t">
             <a:spAutoFit/>
           </a:bodyPr>
           <a:lstStyle/>
@@ -15886,6 +16196,7 @@
           <a:lstStyle/>
           <a:p>
             <a:pPr algn="ctr"/>
+            <a:endParaRPr/>
           </a:p>
         </p:txBody>
       </p:sp>
@@ -15906,7 +16217,7 @@
           <a:noFill/>
         </p:spPr>
         <p:txBody>
-          <a:bodyPr wrap="square" anchor="t" lIns="0" rIns="0" tIns="0" bIns="0">
+          <a:bodyPr wrap="square" lIns="0" tIns="0" rIns="0" bIns="0" anchor="t">
             <a:spAutoFit/>
           </a:bodyPr>
           <a:lstStyle/>
@@ -15948,7 +16259,7 @@
           <a:noFill/>
         </p:spPr>
         <p:txBody>
-          <a:bodyPr wrap="square" anchor="t" lIns="0" rIns="0" tIns="0" bIns="0">
+          <a:bodyPr wrap="square" lIns="0" tIns="0" rIns="0" bIns="0" anchor="t">
             <a:spAutoFit/>
           </a:bodyPr>
           <a:lstStyle/>
@@ -15978,11 +16289,23 @@
   <p:clrMapOvr>
     <a:masterClrMapping/>
   </p:clrMapOvr>
+  <mc:AlternateContent xmlns:mc="http://schemas.openxmlformats.org/markup-compatibility/2006">
+    <mc:Choice xmlns:p159="http://schemas.microsoft.com/office/powerpoint/2015/09/main" Requires="p159">
+      <p:transition xmlns:p14="http://schemas.microsoft.com/office/powerpoint/2010/main" spd="slow" p14:dur="2000">
+        <p159:morph option="byObject"/>
+      </p:transition>
+    </mc:Choice>
+    <mc:Fallback>
+      <p:transition spd="slow">
+        <p:fade/>
+      </p:transition>
+    </mc:Fallback>
+  </mc:AlternateContent>
 </p:sld>
 </file>
 
 <file path=ppt/slides/slide5.xml><?xml version="1.0" encoding="utf-8"?>
-<p:sld xmlns:a="http://schemas.openxmlformats.org/drawingml/2006/main" xmlns:p="http://schemas.openxmlformats.org/presentationml/2006/main" xmlns:r="http://schemas.openxmlformats.org/officeDocument/2006/relationships">
+<p:sld xmlns:a="http://schemas.openxmlformats.org/drawingml/2006/main" xmlns:r="http://schemas.openxmlformats.org/officeDocument/2006/relationships" xmlns:p="http://schemas.openxmlformats.org/presentationml/2006/main">
   <p:cSld>
     <p:spTree>
       <p:nvGrpSpPr>
@@ -15990,7 +16313,14 @@
         <p:cNvGrpSpPr/>
         <p:nvPr/>
       </p:nvGrpSpPr>
-      <p:grpSpPr/>
+      <p:grpSpPr>
+        <a:xfrm>
+          <a:off x="0" y="0"/>
+          <a:ext cx="0" cy="0"/>
+          <a:chOff x="0" y="0"/>
+          <a:chExt cx="0" cy="0"/>
+        </a:xfrm>
+      </p:grpSpPr>
       <p:sp>
         <p:nvSpPr>
           <p:cNvPr id="2" name="Rectangle 1"/>
@@ -16032,6 +16362,7 @@
           <a:lstStyle/>
           <a:p>
             <a:pPr algn="ctr"/>
+            <a:endParaRPr/>
           </a:p>
         </p:txBody>
       </p:sp>
@@ -16076,6 +16407,7 @@
           <a:lstStyle/>
           <a:p>
             <a:pPr algn="ctr"/>
+            <a:endParaRPr/>
           </a:p>
         </p:txBody>
       </p:sp>
@@ -16096,7 +16428,7 @@
           <a:noFill/>
         </p:spPr>
         <p:txBody>
-          <a:bodyPr wrap="square" anchor="t" lIns="0" rIns="0" tIns="0" bIns="0">
+          <a:bodyPr wrap="square" lIns="0" tIns="0" rIns="0" bIns="0" anchor="t">
             <a:spAutoFit/>
           </a:bodyPr>
           <a:lstStyle/>
@@ -16138,7 +16470,7 @@
           <a:noFill/>
         </p:spPr>
         <p:txBody>
-          <a:bodyPr wrap="square" anchor="t" lIns="0" rIns="0" tIns="0" bIns="0">
+          <a:bodyPr wrap="square" lIns="0" tIns="0" rIns="0" bIns="0" anchor="t">
             <a:spAutoFit/>
           </a:bodyPr>
           <a:lstStyle/>
@@ -16228,6 +16560,7 @@
           <a:lstStyle/>
           <a:p>
             <a:pPr algn="ctr"/>
+            <a:endParaRPr/>
           </a:p>
         </p:txBody>
       </p:sp>
@@ -16272,6 +16605,7 @@
           <a:lstStyle/>
           <a:p>
             <a:pPr algn="ctr"/>
+            <a:endParaRPr/>
           </a:p>
         </p:txBody>
       </p:sp>
@@ -16292,7 +16626,7 @@
           <a:noFill/>
         </p:spPr>
         <p:txBody>
-          <a:bodyPr wrap="square" anchor="t" lIns="0" rIns="0" tIns="0" bIns="0">
+          <a:bodyPr wrap="square" lIns="0" tIns="0" rIns="0" bIns="0" anchor="t">
             <a:spAutoFit/>
           </a:bodyPr>
           <a:lstStyle/>
@@ -16334,7 +16668,7 @@
           <a:noFill/>
         </p:spPr>
         <p:txBody>
-          <a:bodyPr wrap="square" anchor="t" lIns="0" rIns="0" tIns="0" bIns="0">
+          <a:bodyPr wrap="square" lIns="0" tIns="0" rIns="0" bIns="0" anchor="t">
             <a:spAutoFit/>
           </a:bodyPr>
           <a:lstStyle/>
@@ -16376,7 +16710,7 @@
           <a:noFill/>
         </p:spPr>
         <p:txBody>
-          <a:bodyPr wrap="square" anchor="t" lIns="0" rIns="0" tIns="0" bIns="0">
+          <a:bodyPr wrap="square" lIns="0" tIns="0" rIns="0" bIns="0" anchor="t">
             <a:spAutoFit/>
           </a:bodyPr>
           <a:lstStyle/>
@@ -16443,6 +16777,7 @@
           <a:lstStyle/>
           <a:p>
             <a:pPr algn="ctr"/>
+            <a:endParaRPr/>
           </a:p>
         </p:txBody>
       </p:sp>
@@ -16487,6 +16822,7 @@
           <a:lstStyle/>
           <a:p>
             <a:pPr algn="ctr"/>
+            <a:endParaRPr/>
           </a:p>
         </p:txBody>
       </p:sp>
@@ -16531,6 +16867,7 @@
           <a:lstStyle/>
           <a:p>
             <a:pPr algn="ctr"/>
+            <a:endParaRPr/>
           </a:p>
         </p:txBody>
       </p:sp>
@@ -16551,7 +16888,7 @@
           <a:noFill/>
         </p:spPr>
         <p:txBody>
-          <a:bodyPr wrap="square" anchor="t" lIns="0" rIns="0" tIns="0" bIns="0">
+          <a:bodyPr wrap="square" lIns="0" tIns="0" rIns="0" bIns="0" anchor="t">
             <a:spAutoFit/>
           </a:bodyPr>
           <a:lstStyle/>
@@ -16593,7 +16930,7 @@
           <a:noFill/>
         </p:spPr>
         <p:txBody>
-          <a:bodyPr wrap="square" anchor="t" lIns="0" rIns="0" tIns="0" bIns="0">
+          <a:bodyPr wrap="square" lIns="0" tIns="0" rIns="0" bIns="0" anchor="t">
             <a:spAutoFit/>
           </a:bodyPr>
           <a:lstStyle/>
@@ -16635,7 +16972,7 @@
           <a:noFill/>
         </p:spPr>
         <p:txBody>
-          <a:bodyPr wrap="square" anchor="t" lIns="0" rIns="0" tIns="0" bIns="0">
+          <a:bodyPr wrap="square" lIns="0" tIns="0" rIns="0" bIns="0" anchor="t">
             <a:spAutoFit/>
           </a:bodyPr>
           <a:lstStyle/>
@@ -16702,6 +17039,7 @@
           <a:lstStyle/>
           <a:p>
             <a:pPr algn="ctr"/>
+            <a:endParaRPr/>
           </a:p>
         </p:txBody>
       </p:sp>
@@ -16746,6 +17084,7 @@
           <a:lstStyle/>
           <a:p>
             <a:pPr algn="ctr"/>
+            <a:endParaRPr/>
           </a:p>
         </p:txBody>
       </p:sp>
@@ -16790,6 +17129,7 @@
           <a:lstStyle/>
           <a:p>
             <a:pPr algn="ctr"/>
+            <a:endParaRPr/>
           </a:p>
         </p:txBody>
       </p:sp>
@@ -16810,7 +17150,7 @@
           <a:noFill/>
         </p:spPr>
         <p:txBody>
-          <a:bodyPr wrap="square" anchor="t" lIns="0" rIns="0" tIns="0" bIns="0">
+          <a:bodyPr wrap="square" lIns="0" tIns="0" rIns="0" bIns="0" anchor="t">
             <a:spAutoFit/>
           </a:bodyPr>
           <a:lstStyle/>
@@ -16852,7 +17192,7 @@
           <a:noFill/>
         </p:spPr>
         <p:txBody>
-          <a:bodyPr wrap="square" anchor="t" lIns="0" rIns="0" tIns="0" bIns="0">
+          <a:bodyPr wrap="square" lIns="0" tIns="0" rIns="0" bIns="0" anchor="t">
             <a:spAutoFit/>
           </a:bodyPr>
           <a:lstStyle/>
@@ -16894,7 +17234,7 @@
           <a:noFill/>
         </p:spPr>
         <p:txBody>
-          <a:bodyPr wrap="square" anchor="t" lIns="0" rIns="0" tIns="0" bIns="0">
+          <a:bodyPr wrap="square" lIns="0" tIns="0" rIns="0" bIns="0" anchor="t">
             <a:spAutoFit/>
           </a:bodyPr>
           <a:lstStyle/>
@@ -16937,7 +17277,7 @@
           <a:noFill/>
         </p:spPr>
         <p:txBody>
-          <a:bodyPr wrap="square" anchor="t" lIns="0" rIns="0" tIns="0" bIns="0">
+          <a:bodyPr wrap="square" lIns="0" tIns="0" rIns="0" bIns="0" anchor="t">
             <a:spAutoFit/>
           </a:bodyPr>
           <a:lstStyle/>
@@ -17003,6 +17343,7 @@
           <a:lstStyle/>
           <a:p>
             <a:pPr algn="ctr"/>
+            <a:endParaRPr/>
           </a:p>
         </p:txBody>
       </p:sp>
@@ -17023,7 +17364,7 @@
           <a:noFill/>
         </p:spPr>
         <p:txBody>
-          <a:bodyPr wrap="square" anchor="t" lIns="0" rIns="0" tIns="0" bIns="0">
+          <a:bodyPr wrap="square" lIns="0" tIns="0" rIns="0" bIns="0" anchor="t">
             <a:spAutoFit/>
           </a:bodyPr>
           <a:lstStyle/>
@@ -17089,6 +17430,7 @@
           <a:lstStyle/>
           <a:p>
             <a:pPr algn="ctr"/>
+            <a:endParaRPr/>
           </a:p>
         </p:txBody>
       </p:sp>
@@ -17109,7 +17451,7 @@
           <a:noFill/>
         </p:spPr>
         <p:txBody>
-          <a:bodyPr wrap="square" anchor="t" lIns="0" rIns="0" tIns="0" bIns="0">
+          <a:bodyPr wrap="square" lIns="0" tIns="0" rIns="0" bIns="0" anchor="t">
             <a:spAutoFit/>
           </a:bodyPr>
           <a:lstStyle/>
@@ -17175,6 +17517,7 @@
           <a:lstStyle/>
           <a:p>
             <a:pPr algn="ctr"/>
+            <a:endParaRPr/>
           </a:p>
         </p:txBody>
       </p:sp>
@@ -17195,7 +17538,7 @@
           <a:noFill/>
         </p:spPr>
         <p:txBody>
-          <a:bodyPr wrap="square" anchor="t" lIns="0" rIns="0" tIns="0" bIns="0">
+          <a:bodyPr wrap="square" lIns="0" tIns="0" rIns="0" bIns="0" anchor="t">
             <a:spAutoFit/>
           </a:bodyPr>
           <a:lstStyle/>
@@ -17261,6 +17604,7 @@
           <a:lstStyle/>
           <a:p>
             <a:pPr algn="ctr"/>
+            <a:endParaRPr/>
           </a:p>
         </p:txBody>
       </p:sp>
@@ -17281,7 +17625,7 @@
           <a:noFill/>
         </p:spPr>
         <p:txBody>
-          <a:bodyPr wrap="square" anchor="t" lIns="0" rIns="0" tIns="0" bIns="0">
+          <a:bodyPr wrap="square" lIns="0" tIns="0" rIns="0" bIns="0" anchor="t">
             <a:spAutoFit/>
           </a:bodyPr>
           <a:lstStyle/>
@@ -17323,7 +17667,7 @@
           <a:noFill/>
         </p:spPr>
         <p:txBody>
-          <a:bodyPr wrap="square" anchor="t" lIns="0" rIns="0" tIns="0" bIns="0">
+          <a:bodyPr wrap="square" lIns="0" tIns="0" rIns="0" bIns="0" anchor="t">
             <a:spAutoFit/>
           </a:bodyPr>
           <a:lstStyle/>
@@ -17353,11 +17697,23 @@
   <p:clrMapOvr>
     <a:masterClrMapping/>
   </p:clrMapOvr>
+  <mc:AlternateContent xmlns:mc="http://schemas.openxmlformats.org/markup-compatibility/2006">
+    <mc:Choice xmlns:p159="http://schemas.microsoft.com/office/powerpoint/2015/09/main" Requires="p159">
+      <p:transition xmlns:p14="http://schemas.microsoft.com/office/powerpoint/2010/main" spd="slow" p14:dur="2000">
+        <p159:morph option="byObject"/>
+      </p:transition>
+    </mc:Choice>
+    <mc:Fallback>
+      <p:transition spd="slow">
+        <p:fade/>
+      </p:transition>
+    </mc:Fallback>
+  </mc:AlternateContent>
 </p:sld>
 </file>
 
 <file path=ppt/slides/slide6.xml><?xml version="1.0" encoding="utf-8"?>
-<p:sld xmlns:a="http://schemas.openxmlformats.org/drawingml/2006/main" xmlns:p="http://schemas.openxmlformats.org/presentationml/2006/main" xmlns:r="http://schemas.openxmlformats.org/officeDocument/2006/relationships">
+<p:sld xmlns:a="http://schemas.openxmlformats.org/drawingml/2006/main" xmlns:r="http://schemas.openxmlformats.org/officeDocument/2006/relationships" xmlns:p="http://schemas.openxmlformats.org/presentationml/2006/main">
   <p:cSld>
     <p:spTree>
       <p:nvGrpSpPr>
@@ -17365,7 +17721,14 @@
         <p:cNvGrpSpPr/>
         <p:nvPr/>
       </p:nvGrpSpPr>
-      <p:grpSpPr/>
+      <p:grpSpPr>
+        <a:xfrm>
+          <a:off x="0" y="0"/>
+          <a:ext cx="0" cy="0"/>
+          <a:chOff x="0" y="0"/>
+          <a:chExt cx="0" cy="0"/>
+        </a:xfrm>
+      </p:grpSpPr>
       <p:sp>
         <p:nvSpPr>
           <p:cNvPr id="2" name="Rectangle 1"/>
@@ -17407,6 +17770,7 @@
           <a:lstStyle/>
           <a:p>
             <a:pPr algn="ctr"/>
+            <a:endParaRPr/>
           </a:p>
         </p:txBody>
       </p:sp>
@@ -17451,6 +17815,7 @@
           <a:lstStyle/>
           <a:p>
             <a:pPr algn="ctr"/>
+            <a:endParaRPr/>
           </a:p>
         </p:txBody>
       </p:sp>
@@ -17471,7 +17836,7 @@
           <a:noFill/>
         </p:spPr>
         <p:txBody>
-          <a:bodyPr wrap="square" anchor="t" lIns="0" rIns="0" tIns="0" bIns="0">
+          <a:bodyPr wrap="square" lIns="0" tIns="0" rIns="0" bIns="0" anchor="t">
             <a:spAutoFit/>
           </a:bodyPr>
           <a:lstStyle/>
@@ -17513,7 +17878,7 @@
           <a:noFill/>
         </p:spPr>
         <p:txBody>
-          <a:bodyPr wrap="square" anchor="t" lIns="0" rIns="0" tIns="0" bIns="0">
+          <a:bodyPr wrap="square" lIns="0" tIns="0" rIns="0" bIns="0" anchor="t">
             <a:spAutoFit/>
           </a:bodyPr>
           <a:lstStyle/>
@@ -17603,6 +17968,7 @@
           <a:lstStyle/>
           <a:p>
             <a:pPr algn="ctr"/>
+            <a:endParaRPr/>
           </a:p>
         </p:txBody>
       </p:sp>
@@ -17623,7 +17989,7 @@
           <a:noFill/>
         </p:spPr>
         <p:txBody>
-          <a:bodyPr wrap="square" anchor="t" lIns="0" rIns="0" tIns="0" bIns="0">
+          <a:bodyPr wrap="square" lIns="0" tIns="0" rIns="0" bIns="0" anchor="t">
             <a:spAutoFit/>
           </a:bodyPr>
           <a:lstStyle/>
@@ -17689,6 +18055,7 @@
           <a:lstStyle/>
           <a:p>
             <a:pPr algn="ctr"/>
+            <a:endParaRPr/>
           </a:p>
         </p:txBody>
       </p:sp>
@@ -17709,7 +18076,7 @@
           <a:noFill/>
         </p:spPr>
         <p:txBody>
-          <a:bodyPr wrap="square" anchor="t" lIns="0" rIns="0" tIns="0" bIns="0">
+          <a:bodyPr wrap="square" lIns="0" tIns="0" rIns="0" bIns="0" anchor="t">
             <a:spAutoFit/>
           </a:bodyPr>
           <a:lstStyle/>
@@ -17775,6 +18142,7 @@
           <a:lstStyle/>
           <a:p>
             <a:pPr algn="ctr"/>
+            <a:endParaRPr/>
           </a:p>
         </p:txBody>
       </p:sp>
@@ -17795,7 +18163,7 @@
           <a:noFill/>
         </p:spPr>
         <p:txBody>
-          <a:bodyPr wrap="square" anchor="t" lIns="0" rIns="0" tIns="0" bIns="0">
+          <a:bodyPr wrap="square" lIns="0" tIns="0" rIns="0" bIns="0" anchor="t">
             <a:spAutoFit/>
           </a:bodyPr>
           <a:lstStyle/>
@@ -17861,6 +18229,7 @@
           <a:lstStyle/>
           <a:p>
             <a:pPr algn="ctr"/>
+            <a:endParaRPr/>
           </a:p>
         </p:txBody>
       </p:sp>
@@ -17929,6 +18298,7 @@
           <a:lstStyle/>
           <a:p>
             <a:pPr algn="ctr"/>
+            <a:endParaRPr/>
           </a:p>
         </p:txBody>
       </p:sp>
@@ -17949,7 +18319,7 @@
           <a:noFill/>
         </p:spPr>
         <p:txBody>
-          <a:bodyPr wrap="square" anchor="t" lIns="0" rIns="0" tIns="0" bIns="0">
+          <a:bodyPr wrap="square" lIns="0" tIns="0" rIns="0" bIns="0" anchor="t">
             <a:spAutoFit/>
           </a:bodyPr>
           <a:lstStyle/>
@@ -17991,7 +18361,7 @@
           <a:noFill/>
         </p:spPr>
         <p:txBody>
-          <a:bodyPr wrap="square" anchor="t" lIns="0" rIns="0" tIns="0" bIns="0">
+          <a:bodyPr wrap="square" lIns="0" tIns="0" rIns="0" bIns="0" anchor="t">
             <a:spAutoFit/>
           </a:bodyPr>
           <a:lstStyle/>
@@ -18021,11 +18391,23 @@
   <p:clrMapOvr>
     <a:masterClrMapping/>
   </p:clrMapOvr>
+  <mc:AlternateContent xmlns:mc="http://schemas.openxmlformats.org/markup-compatibility/2006">
+    <mc:Choice xmlns:p159="http://schemas.microsoft.com/office/powerpoint/2015/09/main" Requires="p159">
+      <p:transition xmlns:p14="http://schemas.microsoft.com/office/powerpoint/2010/main" spd="slow" p14:dur="2000">
+        <p159:morph option="byObject"/>
+      </p:transition>
+    </mc:Choice>
+    <mc:Fallback>
+      <p:transition spd="slow">
+        <p:fade/>
+      </p:transition>
+    </mc:Fallback>
+  </mc:AlternateContent>
 </p:sld>
 </file>
 
 <file path=ppt/slides/slide7.xml><?xml version="1.0" encoding="utf-8"?>
-<p:sld xmlns:a="http://schemas.openxmlformats.org/drawingml/2006/main" xmlns:p="http://schemas.openxmlformats.org/presentationml/2006/main" xmlns:r="http://schemas.openxmlformats.org/officeDocument/2006/relationships">
+<p:sld xmlns:a="http://schemas.openxmlformats.org/drawingml/2006/main" xmlns:r="http://schemas.openxmlformats.org/officeDocument/2006/relationships" xmlns:p="http://schemas.openxmlformats.org/presentationml/2006/main">
   <p:cSld>
     <p:spTree>
       <p:nvGrpSpPr>
@@ -18033,7 +18415,14 @@
         <p:cNvGrpSpPr/>
         <p:nvPr/>
       </p:nvGrpSpPr>
-      <p:grpSpPr/>
+      <p:grpSpPr>
+        <a:xfrm>
+          <a:off x="0" y="0"/>
+          <a:ext cx="0" cy="0"/>
+          <a:chOff x="0" y="0"/>
+          <a:chExt cx="0" cy="0"/>
+        </a:xfrm>
+      </p:grpSpPr>
       <p:sp>
         <p:nvSpPr>
           <p:cNvPr id="2" name="Rectangle 1"/>
@@ -18075,6 +18464,7 @@
           <a:lstStyle/>
           <a:p>
             <a:pPr algn="ctr"/>
+            <a:endParaRPr/>
           </a:p>
         </p:txBody>
       </p:sp>
@@ -18119,6 +18509,7 @@
           <a:lstStyle/>
           <a:p>
             <a:pPr algn="ctr"/>
+            <a:endParaRPr/>
           </a:p>
         </p:txBody>
       </p:sp>
@@ -18139,7 +18530,7 @@
           <a:noFill/>
         </p:spPr>
         <p:txBody>
-          <a:bodyPr wrap="square" anchor="t" lIns="0" rIns="0" tIns="0" bIns="0">
+          <a:bodyPr wrap="square" lIns="0" tIns="0" rIns="0" bIns="0" anchor="t">
             <a:spAutoFit/>
           </a:bodyPr>
           <a:lstStyle/>
@@ -18181,7 +18572,7 @@
           <a:noFill/>
         </p:spPr>
         <p:txBody>
-          <a:bodyPr wrap="square" anchor="t" lIns="0" rIns="0" tIns="0" bIns="0">
+          <a:bodyPr wrap="square" lIns="0" tIns="0" rIns="0" bIns="0" anchor="t">
             <a:spAutoFit/>
           </a:bodyPr>
           <a:lstStyle/>
@@ -18271,6 +18662,7 @@
           <a:lstStyle/>
           <a:p>
             <a:pPr algn="ctr"/>
+            <a:endParaRPr/>
           </a:p>
         </p:txBody>
       </p:sp>
@@ -18291,7 +18683,7 @@
           <a:noFill/>
         </p:spPr>
         <p:txBody>
-          <a:bodyPr wrap="square" anchor="t" lIns="0" rIns="0" tIns="0" bIns="0">
+          <a:bodyPr wrap="square" lIns="0" tIns="0" rIns="0" bIns="0" anchor="t">
             <a:spAutoFit/>
           </a:bodyPr>
           <a:lstStyle/>
@@ -18357,6 +18749,7 @@
           <a:lstStyle/>
           <a:p>
             <a:pPr algn="ctr"/>
+            <a:endParaRPr/>
           </a:p>
         </p:txBody>
       </p:sp>
@@ -18377,7 +18770,7 @@
           <a:noFill/>
         </p:spPr>
         <p:txBody>
-          <a:bodyPr wrap="square" anchor="t" lIns="0" rIns="0" tIns="0" bIns="0">
+          <a:bodyPr wrap="square" lIns="0" tIns="0" rIns="0" bIns="0" anchor="t">
             <a:spAutoFit/>
           </a:bodyPr>
           <a:lstStyle/>
@@ -18443,6 +18836,7 @@
           <a:lstStyle/>
           <a:p>
             <a:pPr algn="ctr"/>
+            <a:endParaRPr/>
           </a:p>
         </p:txBody>
       </p:sp>
@@ -18463,7 +18857,7 @@
           <a:noFill/>
         </p:spPr>
         <p:txBody>
-          <a:bodyPr wrap="square" anchor="t" lIns="0" rIns="0" tIns="0" bIns="0">
+          <a:bodyPr wrap="square" lIns="0" tIns="0" rIns="0" bIns="0" anchor="t">
             <a:spAutoFit/>
           </a:bodyPr>
           <a:lstStyle/>
@@ -18529,6 +18923,7 @@
           <a:lstStyle/>
           <a:p>
             <a:pPr algn="ctr"/>
+            <a:endParaRPr/>
           </a:p>
         </p:txBody>
       </p:sp>
@@ -18597,6 +18992,7 @@
           <a:lstStyle/>
           <a:p>
             <a:pPr algn="ctr"/>
+            <a:endParaRPr/>
           </a:p>
         </p:txBody>
       </p:sp>
@@ -18617,7 +19013,7 @@
           <a:noFill/>
         </p:spPr>
         <p:txBody>
-          <a:bodyPr wrap="square" anchor="t" lIns="0" rIns="0" tIns="0" bIns="0">
+          <a:bodyPr wrap="square" lIns="0" tIns="0" rIns="0" bIns="0" anchor="t">
             <a:spAutoFit/>
           </a:bodyPr>
           <a:lstStyle/>
@@ -18659,7 +19055,7 @@
           <a:noFill/>
         </p:spPr>
         <p:txBody>
-          <a:bodyPr wrap="square" anchor="t" lIns="0" rIns="0" tIns="0" bIns="0">
+          <a:bodyPr wrap="square" lIns="0" tIns="0" rIns="0" bIns="0" anchor="t">
             <a:spAutoFit/>
           </a:bodyPr>
           <a:lstStyle/>
@@ -18689,11 +19085,23 @@
   <p:clrMapOvr>
     <a:masterClrMapping/>
   </p:clrMapOvr>
+  <mc:AlternateContent xmlns:mc="http://schemas.openxmlformats.org/markup-compatibility/2006">
+    <mc:Choice xmlns:p159="http://schemas.microsoft.com/office/powerpoint/2015/09/main" Requires="p159">
+      <p:transition xmlns:p14="http://schemas.microsoft.com/office/powerpoint/2010/main" spd="slow" p14:dur="2000">
+        <p159:morph option="byObject"/>
+      </p:transition>
+    </mc:Choice>
+    <mc:Fallback>
+      <p:transition spd="slow">
+        <p:fade/>
+      </p:transition>
+    </mc:Fallback>
+  </mc:AlternateContent>
 </p:sld>
 </file>
 
 <file path=ppt/slides/slide8.xml><?xml version="1.0" encoding="utf-8"?>
-<p:sld xmlns:a="http://schemas.openxmlformats.org/drawingml/2006/main" xmlns:p="http://schemas.openxmlformats.org/presentationml/2006/main" xmlns:r="http://schemas.openxmlformats.org/officeDocument/2006/relationships">
+<p:sld xmlns:a="http://schemas.openxmlformats.org/drawingml/2006/main" xmlns:r="http://schemas.openxmlformats.org/officeDocument/2006/relationships" xmlns:p="http://schemas.openxmlformats.org/presentationml/2006/main">
   <p:cSld>
     <p:spTree>
       <p:nvGrpSpPr>
@@ -18701,7 +19109,14 @@
         <p:cNvGrpSpPr/>
         <p:nvPr/>
       </p:nvGrpSpPr>
-      <p:grpSpPr/>
+      <p:grpSpPr>
+        <a:xfrm>
+          <a:off x="0" y="0"/>
+          <a:ext cx="0" cy="0"/>
+          <a:chOff x="0" y="0"/>
+          <a:chExt cx="0" cy="0"/>
+        </a:xfrm>
+      </p:grpSpPr>
       <p:sp>
         <p:nvSpPr>
           <p:cNvPr id="2" name="Rectangle 1"/>
@@ -18743,6 +19158,7 @@
           <a:lstStyle/>
           <a:p>
             <a:pPr algn="ctr"/>
+            <a:endParaRPr/>
           </a:p>
         </p:txBody>
       </p:sp>
@@ -18787,6 +19203,7 @@
           <a:lstStyle/>
           <a:p>
             <a:pPr algn="ctr"/>
+            <a:endParaRPr/>
           </a:p>
         </p:txBody>
       </p:sp>
@@ -18807,7 +19224,7 @@
           <a:noFill/>
         </p:spPr>
         <p:txBody>
-          <a:bodyPr wrap="square" anchor="t" lIns="0" rIns="0" tIns="0" bIns="0">
+          <a:bodyPr wrap="square" lIns="0" tIns="0" rIns="0" bIns="0" anchor="t">
             <a:spAutoFit/>
           </a:bodyPr>
           <a:lstStyle/>
@@ -18849,7 +19266,7 @@
           <a:noFill/>
         </p:spPr>
         <p:txBody>
-          <a:bodyPr wrap="square" anchor="t" lIns="0" rIns="0" tIns="0" bIns="0">
+          <a:bodyPr wrap="square" lIns="0" tIns="0" rIns="0" bIns="0" anchor="t">
             <a:spAutoFit/>
           </a:bodyPr>
           <a:lstStyle/>
@@ -18939,6 +19356,7 @@
           <a:lstStyle/>
           <a:p>
             <a:pPr algn="ctr"/>
+            <a:endParaRPr/>
           </a:p>
         </p:txBody>
       </p:sp>
@@ -18959,7 +19377,7 @@
           <a:noFill/>
         </p:spPr>
         <p:txBody>
-          <a:bodyPr wrap="square" anchor="t" lIns="0" rIns="0" tIns="0" bIns="0">
+          <a:bodyPr wrap="square" lIns="0" tIns="0" rIns="0" bIns="0" anchor="t">
             <a:spAutoFit/>
           </a:bodyPr>
           <a:lstStyle/>
@@ -19025,6 +19443,7 @@
           <a:lstStyle/>
           <a:p>
             <a:pPr algn="ctr"/>
+            <a:endParaRPr/>
           </a:p>
         </p:txBody>
       </p:sp>
@@ -19045,7 +19464,7 @@
           <a:noFill/>
         </p:spPr>
         <p:txBody>
-          <a:bodyPr wrap="square" anchor="t" lIns="0" rIns="0" tIns="0" bIns="0">
+          <a:bodyPr wrap="square" lIns="0" tIns="0" rIns="0" bIns="0" anchor="t">
             <a:spAutoFit/>
           </a:bodyPr>
           <a:lstStyle/>
@@ -19111,6 +19530,7 @@
           <a:lstStyle/>
           <a:p>
             <a:pPr algn="ctr"/>
+            <a:endParaRPr/>
           </a:p>
         </p:txBody>
       </p:sp>
@@ -19131,7 +19551,7 @@
           <a:noFill/>
         </p:spPr>
         <p:txBody>
-          <a:bodyPr wrap="square" anchor="t" lIns="0" rIns="0" tIns="0" bIns="0">
+          <a:bodyPr wrap="square" lIns="0" tIns="0" rIns="0" bIns="0" anchor="t">
             <a:spAutoFit/>
           </a:bodyPr>
           <a:lstStyle/>
@@ -19197,6 +19617,7 @@
           <a:lstStyle/>
           <a:p>
             <a:pPr algn="ctr"/>
+            <a:endParaRPr/>
           </a:p>
         </p:txBody>
       </p:sp>
@@ -19265,6 +19686,7 @@
           <a:lstStyle/>
           <a:p>
             <a:pPr algn="ctr"/>
+            <a:endParaRPr/>
           </a:p>
         </p:txBody>
       </p:sp>
@@ -19285,7 +19707,7 @@
           <a:noFill/>
         </p:spPr>
         <p:txBody>
-          <a:bodyPr wrap="square" anchor="t" lIns="0" rIns="0" tIns="0" bIns="0">
+          <a:bodyPr wrap="square" lIns="0" tIns="0" rIns="0" bIns="0" anchor="t">
             <a:spAutoFit/>
           </a:bodyPr>
           <a:lstStyle/>
@@ -19327,7 +19749,7 @@
           <a:noFill/>
         </p:spPr>
         <p:txBody>
-          <a:bodyPr wrap="square" anchor="t" lIns="0" rIns="0" tIns="0" bIns="0">
+          <a:bodyPr wrap="square" lIns="0" tIns="0" rIns="0" bIns="0" anchor="t">
             <a:spAutoFit/>
           </a:bodyPr>
           <a:lstStyle/>
@@ -19357,11 +19779,23 @@
   <p:clrMapOvr>
     <a:masterClrMapping/>
   </p:clrMapOvr>
+  <mc:AlternateContent xmlns:mc="http://schemas.openxmlformats.org/markup-compatibility/2006">
+    <mc:Choice xmlns:p159="http://schemas.microsoft.com/office/powerpoint/2015/09/main" Requires="p159">
+      <p:transition xmlns:p14="http://schemas.microsoft.com/office/powerpoint/2010/main" spd="slow" p14:dur="2000">
+        <p159:morph option="byObject"/>
+      </p:transition>
+    </mc:Choice>
+    <mc:Fallback>
+      <p:transition spd="slow">
+        <p:fade/>
+      </p:transition>
+    </mc:Fallback>
+  </mc:AlternateContent>
 </p:sld>
 </file>
 
 <file path=ppt/slides/slide9.xml><?xml version="1.0" encoding="utf-8"?>
-<p:sld xmlns:a="http://schemas.openxmlformats.org/drawingml/2006/main" xmlns:p="http://schemas.openxmlformats.org/presentationml/2006/main" xmlns:r="http://schemas.openxmlformats.org/officeDocument/2006/relationships">
+<p:sld xmlns:a="http://schemas.openxmlformats.org/drawingml/2006/main" xmlns:r="http://schemas.openxmlformats.org/officeDocument/2006/relationships" xmlns:p="http://schemas.openxmlformats.org/presentationml/2006/main">
   <p:cSld>
     <p:spTree>
       <p:nvGrpSpPr>
@@ -19369,7 +19803,14 @@
         <p:cNvGrpSpPr/>
         <p:nvPr/>
       </p:nvGrpSpPr>
-      <p:grpSpPr/>
+      <p:grpSpPr>
+        <a:xfrm>
+          <a:off x="0" y="0"/>
+          <a:ext cx="0" cy="0"/>
+          <a:chOff x="0" y="0"/>
+          <a:chExt cx="0" cy="0"/>
+        </a:xfrm>
+      </p:grpSpPr>
       <p:sp>
         <p:nvSpPr>
           <p:cNvPr id="2" name="Rectangle 1"/>
@@ -19411,6 +19852,7 @@
           <a:lstStyle/>
           <a:p>
             <a:pPr algn="ctr"/>
+            <a:endParaRPr/>
           </a:p>
         </p:txBody>
       </p:sp>
@@ -19455,6 +19897,7 @@
           <a:lstStyle/>
           <a:p>
             <a:pPr algn="ctr"/>
+            <a:endParaRPr/>
           </a:p>
         </p:txBody>
       </p:sp>
@@ -19475,7 +19918,7 @@
           <a:noFill/>
         </p:spPr>
         <p:txBody>
-          <a:bodyPr wrap="square" anchor="t" lIns="0" rIns="0" tIns="0" bIns="0">
+          <a:bodyPr wrap="square" lIns="0" tIns="0" rIns="0" bIns="0" anchor="t">
             <a:spAutoFit/>
           </a:bodyPr>
           <a:lstStyle/>
@@ -19517,7 +19960,7 @@
           <a:noFill/>
         </p:spPr>
         <p:txBody>
-          <a:bodyPr wrap="square" anchor="t" lIns="0" rIns="0" tIns="0" bIns="0">
+          <a:bodyPr wrap="square" lIns="0" tIns="0" rIns="0" bIns="0" anchor="t">
             <a:spAutoFit/>
           </a:bodyPr>
           <a:lstStyle/>
@@ -19607,6 +20050,7 @@
           <a:lstStyle/>
           <a:p>
             <a:pPr algn="ctr"/>
+            <a:endParaRPr/>
           </a:p>
         </p:txBody>
       </p:sp>
@@ -19627,7 +20071,7 @@
           <a:noFill/>
         </p:spPr>
         <p:txBody>
-          <a:bodyPr wrap="square" anchor="t" lIns="0" rIns="0" tIns="0" bIns="0">
+          <a:bodyPr wrap="square" lIns="0" tIns="0" rIns="0" bIns="0" anchor="t">
             <a:spAutoFit/>
           </a:bodyPr>
           <a:lstStyle/>
@@ -19693,6 +20137,7 @@
           <a:lstStyle/>
           <a:p>
             <a:pPr algn="ctr"/>
+            <a:endParaRPr/>
           </a:p>
         </p:txBody>
       </p:sp>
@@ -19713,7 +20158,7 @@
           <a:noFill/>
         </p:spPr>
         <p:txBody>
-          <a:bodyPr wrap="square" anchor="t" lIns="0" rIns="0" tIns="0" bIns="0">
+          <a:bodyPr wrap="square" lIns="0" tIns="0" rIns="0" bIns="0" anchor="t">
             <a:spAutoFit/>
           </a:bodyPr>
           <a:lstStyle/>
@@ -19779,6 +20224,7 @@
           <a:lstStyle/>
           <a:p>
             <a:pPr algn="ctr"/>
+            <a:endParaRPr/>
           </a:p>
         </p:txBody>
       </p:sp>
@@ -19799,7 +20245,7 @@
           <a:noFill/>
         </p:spPr>
         <p:txBody>
-          <a:bodyPr wrap="square" anchor="t" lIns="0" rIns="0" tIns="0" bIns="0">
+          <a:bodyPr wrap="square" lIns="0" tIns="0" rIns="0" bIns="0" anchor="t">
             <a:spAutoFit/>
           </a:bodyPr>
           <a:lstStyle/>
@@ -19865,6 +20311,7 @@
           <a:lstStyle/>
           <a:p>
             <a:pPr algn="ctr"/>
+            <a:endParaRPr/>
           </a:p>
         </p:txBody>
       </p:sp>
@@ -19933,6 +20380,7 @@
           <a:lstStyle/>
           <a:p>
             <a:pPr algn="ctr"/>
+            <a:endParaRPr/>
           </a:p>
         </p:txBody>
       </p:sp>
@@ -19953,7 +20401,7 @@
           <a:noFill/>
         </p:spPr>
         <p:txBody>
-          <a:bodyPr wrap="square" anchor="t" lIns="0" rIns="0" tIns="0" bIns="0">
+          <a:bodyPr wrap="square" lIns="0" tIns="0" rIns="0" bIns="0" anchor="t">
             <a:spAutoFit/>
           </a:bodyPr>
           <a:lstStyle/>
@@ -19995,7 +20443,7 @@
           <a:noFill/>
         </p:spPr>
         <p:txBody>
-          <a:bodyPr wrap="square" anchor="t" lIns="0" rIns="0" tIns="0" bIns="0">
+          <a:bodyPr wrap="square" lIns="0" tIns="0" rIns="0" bIns="0" anchor="t">
             <a:spAutoFit/>
           </a:bodyPr>
           <a:lstStyle/>
@@ -20025,6 +20473,18 @@
   <p:clrMapOvr>
     <a:masterClrMapping/>
   </p:clrMapOvr>
+  <mc:AlternateContent xmlns:mc="http://schemas.openxmlformats.org/markup-compatibility/2006">
+    <mc:Choice xmlns:p159="http://schemas.microsoft.com/office/powerpoint/2015/09/main" Requires="p159">
+      <p:transition xmlns:p14="http://schemas.microsoft.com/office/powerpoint/2010/main" spd="slow" p14:dur="2000">
+        <p159:morph option="byObject"/>
+      </p:transition>
+    </mc:Choice>
+    <mc:Fallback>
+      <p:transition spd="slow">
+        <p:fade/>
+      </p:transition>
+    </mc:Fallback>
+  </mc:AlternateContent>
 </p:sld>
 </file>
 

</xml_diff>